<commit_message>
Rename PPT preview semantics labels
</commit_message>
<xml_diff>
--- a/docs/theme-preview/pptx/clean.pptx
+++ b/docs/theme-preview/pptx/clean.pptx
@@ -10557,7 +10557,7 @@
                 <a:ea typeface="Pretendard" pitchFamily="34" charset="-122"/>
                 <a:cs typeface="Pretendard" pitchFamily="34" charset="-120"/>
               </a:rPr>
-              <a:t>Markdown Semantics</a:t>
+              <a:t>Semantic Blocks</a:t>
             </a:r>
             <a:endParaRPr lang="en-US" sz="2200" dirty="0"/>
           </a:p>
@@ -13772,7 +13772,7 @@
                 <a:ea typeface="Pretendard" pitchFamily="34" charset="-122"/>
                 <a:cs typeface="Pretendard" pitchFamily="34" charset="-120"/>
               </a:rPr>
-              <a:t>Markdown Semantics</a:t>
+              <a:t>Semantic Blocks</a:t>
             </a:r>
             <a:endParaRPr lang="en-US" sz="3400" dirty="0"/>
           </a:p>

</xml_diff>

<commit_message>
Improve TOC lists and trim preview themes
</commit_message>
<xml_diff>
--- a/docs/theme-preview/pptx/clean.pptx
+++ b/docs/theme-preview/pptx/clean.pptx
@@ -125,7 +125,7 @@
 </p:presentation>
 </file>
 
-<file path=ppt/charts/chart3.xml><?xml version="1.0" encoding="utf-8"?>
+<file path=ppt/charts/chart1.xml><?xml version="1.0" encoding="utf-8"?>
 <c:chartSpace xmlns:c="http://schemas.openxmlformats.org/drawingml/2006/chart" xmlns:a="http://schemas.openxmlformats.org/drawingml/2006/main" xmlns:r="http://schemas.openxmlformats.org/officeDocument/2006/relationships">
   <c:date1904 val="0"/>
   <c:roundedCorners val="1"/>
@@ -9606,8 +9606,37 @@
         </p:nvSpPr>
         <p:spPr>
           <a:xfrm>
-            <a:off x="914400" y="1417320"/>
-            <a:ext cx="73152" cy="868680"/>
+            <a:off x="786384" y="1956816"/>
+            <a:ext cx="32004" cy="3483864"/>
+          </a:xfrm>
+          <a:prstGeom prst="rect">
+            <a:avLst/>
+          </a:prstGeom>
+          <a:solidFill>
+            <a:srgbClr val="DBEAFE">
+              <a:alpha val="80000"/>
+            </a:srgbClr>
+          </a:solidFill>
+          <a:ln w="12700">
+            <a:solidFill>
+              <a:srgbClr val="DBEAFE">
+                <a:alpha val="0"/>
+              </a:srgbClr>
+            </a:solidFill>
+            <a:prstDash val="solid"/>
+          </a:ln>
+        </p:spPr>
+      </p:sp>
+      <p:sp>
+        <p:nvSpPr>
+          <p:cNvPr id="4" name="Shape 2"/>
+          <p:cNvSpPr/>
+          <p:nvPr/>
+        </p:nvSpPr>
+        <p:spPr>
+          <a:xfrm>
+            <a:off x="914400" y="1865376"/>
+            <a:ext cx="73152" cy="1024128"/>
           </a:xfrm>
           <a:prstGeom prst="rect">
             <a:avLst/>
@@ -9627,14 +9656,14 @@
       </p:sp>
       <p:sp>
         <p:nvSpPr>
-          <p:cNvPr id="4" name="Shape 2"/>
-          <p:cNvSpPr/>
-          <p:nvPr/>
-        </p:nvSpPr>
-        <p:spPr>
-          <a:xfrm>
-            <a:off x="914400" y="2560320"/>
-            <a:ext cx="73152" cy="868680"/>
+          <p:cNvPr id="5" name="Shape 3"/>
+          <p:cNvSpPr/>
+          <p:nvPr/>
+        </p:nvSpPr>
+        <p:spPr>
+          <a:xfrm>
+            <a:off x="914400" y="3191256"/>
+            <a:ext cx="73152" cy="1024128"/>
           </a:xfrm>
           <a:prstGeom prst="rect">
             <a:avLst/>
@@ -9654,14 +9683,14 @@
       </p:sp>
       <p:sp>
         <p:nvSpPr>
-          <p:cNvPr id="5" name="Shape 3"/>
-          <p:cNvSpPr/>
-          <p:nvPr/>
-        </p:nvSpPr>
-        <p:spPr>
-          <a:xfrm>
-            <a:off x="914400" y="3703320"/>
-            <a:ext cx="73152" cy="868680"/>
+          <p:cNvPr id="6" name="Shape 4"/>
+          <p:cNvSpPr/>
+          <p:nvPr/>
+        </p:nvSpPr>
+        <p:spPr>
+          <a:xfrm>
+            <a:off x="914400" y="4507992"/>
+            <a:ext cx="73152" cy="1024128"/>
           </a:xfrm>
           <a:prstGeom prst="rect">
             <a:avLst/>
@@ -9681,7 +9710,7 @@
       </p:sp>
       <p:pic>
         <p:nvPicPr>
-          <p:cNvPr id="6" name="Image 0" descr="preencoded.png">    </p:cNvPr>
+          <p:cNvPr id="7" name="Image 0" descr="preencoded.png">    </p:cNvPr>
           <p:cNvPicPr>
             <a:picLocks noChangeAspect="1"/>
           </p:cNvPicPr>
@@ -9701,8 +9730,8 @@
         </p:blipFill>
         <p:spPr>
           <a:xfrm>
-            <a:off x="914400" y="1417320"/>
-            <a:ext cx="10241280" cy="868680"/>
+            <a:off x="914400" y="1865376"/>
+            <a:ext cx="10241280" cy="1024128"/>
           </a:xfrm>
           <a:prstGeom prst="rect">
             <a:avLst/>
@@ -9711,14 +9740,14 @@
       </p:pic>
       <p:sp>
         <p:nvSpPr>
-          <p:cNvPr id="7" name="Shape 4"/>
-          <p:cNvSpPr/>
-          <p:nvPr/>
-        </p:nvSpPr>
-        <p:spPr>
-          <a:xfrm>
-            <a:off x="914400" y="1417320"/>
-            <a:ext cx="10241280" cy="868680"/>
+          <p:cNvPr id="8" name="Shape 5"/>
+          <p:cNvSpPr/>
+          <p:nvPr/>
+        </p:nvSpPr>
+        <p:spPr>
+          <a:xfrm>
+            <a:off x="914400" y="1865376"/>
+            <a:ext cx="10241280" cy="1024128"/>
           </a:xfrm>
           <a:prstGeom prst="rect">
             <a:avLst/>
@@ -9747,7 +9776,7 @@
       </p:sp>
       <p:pic>
         <p:nvPicPr>
-          <p:cNvPr id="8" name="Image 1" descr="preencoded.png">    </p:cNvPr>
+          <p:cNvPr id="9" name="Image 1" descr="preencoded.png">    </p:cNvPr>
           <p:cNvPicPr>
             <a:picLocks noChangeAspect="1"/>
           </p:cNvPicPr>
@@ -9767,8 +9796,8 @@
         </p:blipFill>
         <p:spPr>
           <a:xfrm>
-            <a:off x="914400" y="2560320"/>
-            <a:ext cx="10241280" cy="868680"/>
+            <a:off x="914400" y="3191256"/>
+            <a:ext cx="10241280" cy="1024128"/>
           </a:xfrm>
           <a:prstGeom prst="rect">
             <a:avLst/>
@@ -9777,14 +9806,14 @@
       </p:pic>
       <p:sp>
         <p:nvSpPr>
-          <p:cNvPr id="9" name="Shape 5"/>
-          <p:cNvSpPr/>
-          <p:nvPr/>
-        </p:nvSpPr>
-        <p:spPr>
-          <a:xfrm>
-            <a:off x="914400" y="2560320"/>
-            <a:ext cx="10241280" cy="868680"/>
+          <p:cNvPr id="10" name="Shape 6"/>
+          <p:cNvSpPr/>
+          <p:nvPr/>
+        </p:nvSpPr>
+        <p:spPr>
+          <a:xfrm>
+            <a:off x="914400" y="3191256"/>
+            <a:ext cx="10241280" cy="1024128"/>
           </a:xfrm>
           <a:prstGeom prst="rect">
             <a:avLst/>
@@ -9813,7 +9842,7 @@
       </p:sp>
       <p:pic>
         <p:nvPicPr>
-          <p:cNvPr id="10" name="Image 2" descr="preencoded.png">    </p:cNvPr>
+          <p:cNvPr id="11" name="Image 2" descr="preencoded.png">    </p:cNvPr>
           <p:cNvPicPr>
             <a:picLocks noChangeAspect="1"/>
           </p:cNvPicPr>
@@ -9833,8 +9862,8 @@
         </p:blipFill>
         <p:spPr>
           <a:xfrm>
-            <a:off x="914400" y="3703320"/>
-            <a:ext cx="10241280" cy="868680"/>
+            <a:off x="914400" y="4507992"/>
+            <a:ext cx="10241280" cy="1024128"/>
           </a:xfrm>
           <a:prstGeom prst="rect">
             <a:avLst/>
@@ -9843,14 +9872,14 @@
       </p:pic>
       <p:sp>
         <p:nvSpPr>
-          <p:cNvPr id="11" name="Shape 6"/>
-          <p:cNvSpPr/>
-          <p:nvPr/>
-        </p:nvSpPr>
-        <p:spPr>
-          <a:xfrm>
-            <a:off x="914400" y="3703320"/>
-            <a:ext cx="10241280" cy="868680"/>
+          <p:cNvPr id="12" name="Shape 7"/>
+          <p:cNvSpPr/>
+          <p:nvPr/>
+        </p:nvSpPr>
+        <p:spPr>
+          <a:xfrm>
+            <a:off x="914400" y="4507992"/>
+            <a:ext cx="10241280" cy="1024128"/>
           </a:xfrm>
           <a:prstGeom prst="rect">
             <a:avLst/>
@@ -9879,7 +9908,7 @@
       </p:sp>
       <p:sp>
         <p:nvSpPr>
-          <p:cNvPr id="12" name="Text 7"/>
+          <p:cNvPr id="13" name="Text 8"/>
           <p:cNvSpPr txBox="1"/>
           <p:nvPr/>
         </p:nvSpPr>
@@ -9921,18 +9950,18 @@
       </p:sp>
       <p:sp>
         <p:nvSpPr>
-          <p:cNvPr id="13" name="Shape 8"/>
-          <p:cNvSpPr/>
-          <p:nvPr/>
-        </p:nvSpPr>
-        <p:spPr>
-          <a:xfrm>
-            <a:off x="1097280" y="1623060"/>
-            <a:ext cx="457200" cy="457200"/>
+          <p:cNvPr id="14" name="Shape 9"/>
+          <p:cNvSpPr/>
+          <p:nvPr/>
+        </p:nvSpPr>
+        <p:spPr>
+          <a:xfrm>
+            <a:off x="1097280" y="2140428"/>
+            <a:ext cx="474025" cy="474025"/>
           </a:xfrm>
           <a:prstGeom prst="roundRect">
             <a:avLst>
-              <a:gd name="adj" fmla="val 8000"/>
+              <a:gd name="adj" fmla="val 7716"/>
             </a:avLst>
           </a:prstGeom>
           <a:solidFill>
@@ -9948,7 +9977,7 @@
       </p:sp>
       <p:pic>
         <p:nvPicPr>
-          <p:cNvPr id="14" name="Image 3" descr="flow icon from tabler-icons (MIT)">    </p:cNvPr>
+          <p:cNvPr id="15" name="Image 3" descr="flow icon from tabler-icons (MIT)">    </p:cNvPr>
           <p:cNvPicPr>
             <a:picLocks noChangeAspect="1"/>
           </p:cNvPicPr>
@@ -9968,8 +9997,8 @@
         </p:blipFill>
         <p:spPr>
           <a:xfrm>
-            <a:off x="1170432" y="1696212"/>
-            <a:ext cx="310896" cy="310896"/>
+            <a:off x="1170432" y="2213580"/>
+            <a:ext cx="327721" cy="327721"/>
           </a:xfrm>
           <a:prstGeom prst="rect">
             <a:avLst/>
@@ -9978,14 +10007,14 @@
       </p:pic>
       <p:sp>
         <p:nvSpPr>
-          <p:cNvPr id="15" name="Text 9"/>
+          <p:cNvPr id="16" name="Text 10"/>
           <p:cNvSpPr txBox="1"/>
           <p:nvPr/>
         </p:nvSpPr>
         <p:spPr>
           <a:xfrm>
-            <a:off x="1682496" y="1508760"/>
-            <a:ext cx="9272016" cy="685800"/>
+            <a:off x="1699321" y="1957548"/>
+            <a:ext cx="9255191" cy="839785"/>
           </a:xfrm>
           <a:prstGeom prst="rect">
             <a:avLst/>
@@ -10037,18 +10066,18 @@
       </p:sp>
       <p:sp>
         <p:nvSpPr>
-          <p:cNvPr id="16" name="Shape 10"/>
-          <p:cNvSpPr/>
-          <p:nvPr/>
-        </p:nvSpPr>
-        <p:spPr>
-          <a:xfrm>
-            <a:off x="1097280" y="2766060"/>
-            <a:ext cx="457200" cy="457200"/>
+          <p:cNvPr id="17" name="Shape 11"/>
+          <p:cNvSpPr/>
+          <p:nvPr/>
+        </p:nvSpPr>
+        <p:spPr>
+          <a:xfrm>
+            <a:off x="1097280" y="3466308"/>
+            <a:ext cx="474025" cy="474025"/>
           </a:xfrm>
           <a:prstGeom prst="roundRect">
             <a:avLst>
-              <a:gd name="adj" fmla="val 8000"/>
+              <a:gd name="adj" fmla="val 7716"/>
             </a:avLst>
           </a:prstGeom>
           <a:solidFill>
@@ -10064,7 +10093,7 @@
       </p:sp>
       <p:pic>
         <p:nvPicPr>
-          <p:cNvPr id="17" name="Image 4" descr="verified icon from tabler-icons (MIT)">    </p:cNvPr>
+          <p:cNvPr id="18" name="Image 4" descr="verified icon from tabler-icons (MIT)">    </p:cNvPr>
           <p:cNvPicPr>
             <a:picLocks noChangeAspect="1"/>
           </p:cNvPicPr>
@@ -10084,8 +10113,8 @@
         </p:blipFill>
         <p:spPr>
           <a:xfrm>
-            <a:off x="1170432" y="2839212"/>
-            <a:ext cx="310896" cy="310896"/>
+            <a:off x="1170432" y="3539460"/>
+            <a:ext cx="327721" cy="327721"/>
           </a:xfrm>
           <a:prstGeom prst="rect">
             <a:avLst/>
@@ -10094,14 +10123,14 @@
       </p:pic>
       <p:sp>
         <p:nvSpPr>
-          <p:cNvPr id="18" name="Text 11"/>
+          <p:cNvPr id="19" name="Text 12"/>
           <p:cNvSpPr txBox="1"/>
           <p:nvPr/>
         </p:nvSpPr>
         <p:spPr>
           <a:xfrm>
-            <a:off x="1682496" y="2651760"/>
-            <a:ext cx="9272016" cy="685800"/>
+            <a:off x="1699321" y="3283428"/>
+            <a:ext cx="9255191" cy="839785"/>
           </a:xfrm>
           <a:prstGeom prst="rect">
             <a:avLst/>
@@ -10153,18 +10182,18 @@
       </p:sp>
       <p:sp>
         <p:nvSpPr>
-          <p:cNvPr id="19" name="Shape 12"/>
-          <p:cNvSpPr/>
-          <p:nvPr/>
-        </p:nvSpPr>
-        <p:spPr>
-          <a:xfrm>
-            <a:off x="1097280" y="3909060"/>
-            <a:ext cx="457200" cy="457200"/>
+          <p:cNvPr id="20" name="Shape 13"/>
+          <p:cNvSpPr/>
+          <p:nvPr/>
+        </p:nvSpPr>
+        <p:spPr>
+          <a:xfrm>
+            <a:off x="1097280" y="4783044"/>
+            <a:ext cx="474025" cy="474025"/>
           </a:xfrm>
           <a:prstGeom prst="roundRect">
             <a:avLst>
-              <a:gd name="adj" fmla="val 8000"/>
+              <a:gd name="adj" fmla="val 7716"/>
             </a:avLst>
           </a:prstGeom>
           <a:solidFill>
@@ -10180,7 +10209,7 @@
       </p:sp>
       <p:pic>
         <p:nvPicPr>
-          <p:cNvPr id="20" name="Image 5" descr="spark icon from tabler-icons (MIT)">    </p:cNvPr>
+          <p:cNvPr id="21" name="Image 5" descr="spark icon from tabler-icons (MIT)">    </p:cNvPr>
           <p:cNvPicPr>
             <a:picLocks noChangeAspect="1"/>
           </p:cNvPicPr>
@@ -10200,8 +10229,8 @@
         </p:blipFill>
         <p:spPr>
           <a:xfrm>
-            <a:off x="1170432" y="3982212"/>
-            <a:ext cx="310896" cy="310896"/>
+            <a:off x="1170432" y="4856196"/>
+            <a:ext cx="327721" cy="327721"/>
           </a:xfrm>
           <a:prstGeom prst="rect">
             <a:avLst/>
@@ -10210,14 +10239,14 @@
       </p:pic>
       <p:sp>
         <p:nvSpPr>
-          <p:cNvPr id="21" name="Text 13"/>
+          <p:cNvPr id="22" name="Text 14"/>
           <p:cNvSpPr txBox="1"/>
           <p:nvPr/>
         </p:nvSpPr>
         <p:spPr>
           <a:xfrm>
-            <a:off x="1682496" y="3794760"/>
-            <a:ext cx="9272016" cy="685800"/>
+            <a:off x="1699321" y="4600164"/>
+            <a:ext cx="9255191" cy="839785"/>
           </a:xfrm>
           <a:prstGeom prst="rect">
             <a:avLst/>
@@ -10334,8 +10363,8 @@
         </p:nvSpPr>
         <p:spPr>
           <a:xfrm>
-            <a:off x="914400" y="1463040"/>
-            <a:ext cx="10241280" cy="73152"/>
+            <a:off x="822960" y="1188720"/>
+            <a:ext cx="10515600" cy="45720"/>
           </a:xfrm>
           <a:prstGeom prst="rect">
             <a:avLst/>
@@ -10355,7 +10384,387 @@
       </p:sp>
       <p:sp>
         <p:nvSpPr>
-          <p:cNvPr id="4" name="Text 2"/>
+          <p:cNvPr id="4" name="Shape 2"/>
+          <p:cNvSpPr/>
+          <p:nvPr/>
+        </p:nvSpPr>
+        <p:spPr>
+          <a:xfrm>
+            <a:off x="822960" y="6199632"/>
+            <a:ext cx="2011680" cy="45720"/>
+          </a:xfrm>
+          <a:prstGeom prst="rect">
+            <a:avLst/>
+          </a:prstGeom>
+          <a:solidFill>
+            <a:srgbClr val="DBEAFE"/>
+          </a:solidFill>
+          <a:ln w="12700">
+            <a:solidFill>
+              <a:srgbClr val="DBEAFE">
+                <a:alpha val="0"/>
+              </a:srgbClr>
+            </a:solidFill>
+            <a:prstDash val="solid"/>
+          </a:ln>
+        </p:spPr>
+      </p:sp>
+      <p:sp>
+        <p:nvSpPr>
+          <p:cNvPr id="5" name="Shape 3"/>
+          <p:cNvSpPr/>
+          <p:nvPr/>
+        </p:nvSpPr>
+        <p:spPr>
+          <a:xfrm>
+            <a:off x="6080760" y="1389888"/>
+            <a:ext cx="22860" cy="4663440"/>
+          </a:xfrm>
+          <a:prstGeom prst="rect">
+            <a:avLst/>
+          </a:prstGeom>
+          <a:solidFill>
+            <a:srgbClr val="E2E8F0">
+              <a:alpha val="90000"/>
+            </a:srgbClr>
+          </a:solidFill>
+          <a:ln w="12700">
+            <a:solidFill>
+              <a:srgbClr val="E2E8F0">
+                <a:alpha val="0"/>
+              </a:srgbClr>
+            </a:solidFill>
+            <a:prstDash val="solid"/>
+          </a:ln>
+        </p:spPr>
+      </p:sp>
+      <p:sp>
+        <p:nvSpPr>
+          <p:cNvPr id="6" name="Shape 4"/>
+          <p:cNvSpPr/>
+          <p:nvPr/>
+        </p:nvSpPr>
+        <p:spPr>
+          <a:xfrm>
+            <a:off x="822960" y="1389888"/>
+            <a:ext cx="73152" cy="658368"/>
+          </a:xfrm>
+          <a:prstGeom prst="rect">
+            <a:avLst/>
+          </a:prstGeom>
+          <a:solidFill>
+            <a:srgbClr val="2563EB"/>
+          </a:solidFill>
+          <a:ln w="12700">
+            <a:solidFill>
+              <a:srgbClr val="2563EB">
+                <a:alpha val="0"/>
+              </a:srgbClr>
+            </a:solidFill>
+            <a:prstDash val="solid"/>
+          </a:ln>
+        </p:spPr>
+      </p:sp>
+      <p:sp>
+        <p:nvSpPr>
+          <p:cNvPr id="7" name="Shape 5"/>
+          <p:cNvSpPr/>
+          <p:nvPr/>
+        </p:nvSpPr>
+        <p:spPr>
+          <a:xfrm>
+            <a:off x="822960" y="2194560"/>
+            <a:ext cx="73152" cy="658368"/>
+          </a:xfrm>
+          <a:prstGeom prst="rect">
+            <a:avLst/>
+          </a:prstGeom>
+          <a:solidFill>
+            <a:srgbClr val="DBEAFE"/>
+          </a:solidFill>
+          <a:ln w="12700">
+            <a:solidFill>
+              <a:srgbClr val="DBEAFE">
+                <a:alpha val="0"/>
+              </a:srgbClr>
+            </a:solidFill>
+            <a:prstDash val="solid"/>
+          </a:ln>
+        </p:spPr>
+      </p:sp>
+      <p:sp>
+        <p:nvSpPr>
+          <p:cNvPr id="8" name="Shape 6"/>
+          <p:cNvSpPr/>
+          <p:nvPr/>
+        </p:nvSpPr>
+        <p:spPr>
+          <a:xfrm>
+            <a:off x="822960" y="2990088"/>
+            <a:ext cx="73152" cy="658368"/>
+          </a:xfrm>
+          <a:prstGeom prst="rect">
+            <a:avLst/>
+          </a:prstGeom>
+          <a:solidFill>
+            <a:srgbClr val="2563EB"/>
+          </a:solidFill>
+          <a:ln w="12700">
+            <a:solidFill>
+              <a:srgbClr val="2563EB">
+                <a:alpha val="0"/>
+              </a:srgbClr>
+            </a:solidFill>
+            <a:prstDash val="solid"/>
+          </a:ln>
+        </p:spPr>
+      </p:sp>
+      <p:sp>
+        <p:nvSpPr>
+          <p:cNvPr id="9" name="Shape 7"/>
+          <p:cNvSpPr/>
+          <p:nvPr/>
+        </p:nvSpPr>
+        <p:spPr>
+          <a:xfrm>
+            <a:off x="822960" y="3794760"/>
+            <a:ext cx="73152" cy="658368"/>
+          </a:xfrm>
+          <a:prstGeom prst="rect">
+            <a:avLst/>
+          </a:prstGeom>
+          <a:solidFill>
+            <a:srgbClr val="DBEAFE"/>
+          </a:solidFill>
+          <a:ln w="12700">
+            <a:solidFill>
+              <a:srgbClr val="DBEAFE">
+                <a:alpha val="0"/>
+              </a:srgbClr>
+            </a:solidFill>
+            <a:prstDash val="solid"/>
+          </a:ln>
+        </p:spPr>
+      </p:sp>
+      <p:sp>
+        <p:nvSpPr>
+          <p:cNvPr id="10" name="Shape 8"/>
+          <p:cNvSpPr/>
+          <p:nvPr/>
+        </p:nvSpPr>
+        <p:spPr>
+          <a:xfrm>
+            <a:off x="822960" y="4599432"/>
+            <a:ext cx="73152" cy="658368"/>
+          </a:xfrm>
+          <a:prstGeom prst="rect">
+            <a:avLst/>
+          </a:prstGeom>
+          <a:solidFill>
+            <a:srgbClr val="2563EB"/>
+          </a:solidFill>
+          <a:ln w="12700">
+            <a:solidFill>
+              <a:srgbClr val="2563EB">
+                <a:alpha val="0"/>
+              </a:srgbClr>
+            </a:solidFill>
+            <a:prstDash val="solid"/>
+          </a:ln>
+        </p:spPr>
+      </p:sp>
+      <p:sp>
+        <p:nvSpPr>
+          <p:cNvPr id="11" name="Shape 9"/>
+          <p:cNvSpPr/>
+          <p:nvPr/>
+        </p:nvSpPr>
+        <p:spPr>
+          <a:xfrm>
+            <a:off x="822960" y="5394960"/>
+            <a:ext cx="73152" cy="658368"/>
+          </a:xfrm>
+          <a:prstGeom prst="rect">
+            <a:avLst/>
+          </a:prstGeom>
+          <a:solidFill>
+            <a:srgbClr val="DBEAFE"/>
+          </a:solidFill>
+          <a:ln w="12700">
+            <a:solidFill>
+              <a:srgbClr val="DBEAFE">
+                <a:alpha val="0"/>
+              </a:srgbClr>
+            </a:solidFill>
+            <a:prstDash val="solid"/>
+          </a:ln>
+        </p:spPr>
+      </p:sp>
+      <p:sp>
+        <p:nvSpPr>
+          <p:cNvPr id="12" name="Shape 10"/>
+          <p:cNvSpPr/>
+          <p:nvPr/>
+        </p:nvSpPr>
+        <p:spPr>
+          <a:xfrm>
+            <a:off x="6272784" y="1389888"/>
+            <a:ext cx="73152" cy="658368"/>
+          </a:xfrm>
+          <a:prstGeom prst="rect">
+            <a:avLst/>
+          </a:prstGeom>
+          <a:solidFill>
+            <a:srgbClr val="2563EB"/>
+          </a:solidFill>
+          <a:ln w="12700">
+            <a:solidFill>
+              <a:srgbClr val="2563EB">
+                <a:alpha val="0"/>
+              </a:srgbClr>
+            </a:solidFill>
+            <a:prstDash val="solid"/>
+          </a:ln>
+        </p:spPr>
+      </p:sp>
+      <p:sp>
+        <p:nvSpPr>
+          <p:cNvPr id="13" name="Shape 11"/>
+          <p:cNvSpPr/>
+          <p:nvPr/>
+        </p:nvSpPr>
+        <p:spPr>
+          <a:xfrm>
+            <a:off x="6272784" y="2194560"/>
+            <a:ext cx="73152" cy="658368"/>
+          </a:xfrm>
+          <a:prstGeom prst="rect">
+            <a:avLst/>
+          </a:prstGeom>
+          <a:solidFill>
+            <a:srgbClr val="DBEAFE"/>
+          </a:solidFill>
+          <a:ln w="12700">
+            <a:solidFill>
+              <a:srgbClr val="DBEAFE">
+                <a:alpha val="0"/>
+              </a:srgbClr>
+            </a:solidFill>
+            <a:prstDash val="solid"/>
+          </a:ln>
+        </p:spPr>
+      </p:sp>
+      <p:sp>
+        <p:nvSpPr>
+          <p:cNvPr id="14" name="Shape 12"/>
+          <p:cNvSpPr/>
+          <p:nvPr/>
+        </p:nvSpPr>
+        <p:spPr>
+          <a:xfrm>
+            <a:off x="6272784" y="2990088"/>
+            <a:ext cx="73152" cy="658368"/>
+          </a:xfrm>
+          <a:prstGeom prst="rect">
+            <a:avLst/>
+          </a:prstGeom>
+          <a:solidFill>
+            <a:srgbClr val="2563EB"/>
+          </a:solidFill>
+          <a:ln w="12700">
+            <a:solidFill>
+              <a:srgbClr val="2563EB">
+                <a:alpha val="0"/>
+              </a:srgbClr>
+            </a:solidFill>
+            <a:prstDash val="solid"/>
+          </a:ln>
+        </p:spPr>
+      </p:sp>
+      <p:sp>
+        <p:nvSpPr>
+          <p:cNvPr id="15" name="Shape 13"/>
+          <p:cNvSpPr/>
+          <p:nvPr/>
+        </p:nvSpPr>
+        <p:spPr>
+          <a:xfrm>
+            <a:off x="6272784" y="3794760"/>
+            <a:ext cx="73152" cy="658368"/>
+          </a:xfrm>
+          <a:prstGeom prst="rect">
+            <a:avLst/>
+          </a:prstGeom>
+          <a:solidFill>
+            <a:srgbClr val="DBEAFE"/>
+          </a:solidFill>
+          <a:ln w="12700">
+            <a:solidFill>
+              <a:srgbClr val="DBEAFE">
+                <a:alpha val="0"/>
+              </a:srgbClr>
+            </a:solidFill>
+            <a:prstDash val="solid"/>
+          </a:ln>
+        </p:spPr>
+      </p:sp>
+      <p:sp>
+        <p:nvSpPr>
+          <p:cNvPr id="16" name="Shape 14"/>
+          <p:cNvSpPr/>
+          <p:nvPr/>
+        </p:nvSpPr>
+        <p:spPr>
+          <a:xfrm>
+            <a:off x="6272784" y="4599432"/>
+            <a:ext cx="73152" cy="658368"/>
+          </a:xfrm>
+          <a:prstGeom prst="rect">
+            <a:avLst/>
+          </a:prstGeom>
+          <a:solidFill>
+            <a:srgbClr val="2563EB"/>
+          </a:solidFill>
+          <a:ln w="12700">
+            <a:solidFill>
+              <a:srgbClr val="2563EB">
+                <a:alpha val="0"/>
+              </a:srgbClr>
+            </a:solidFill>
+            <a:prstDash val="solid"/>
+          </a:ln>
+        </p:spPr>
+      </p:sp>
+      <p:sp>
+        <p:nvSpPr>
+          <p:cNvPr id="17" name="Shape 15"/>
+          <p:cNvSpPr/>
+          <p:nvPr/>
+        </p:nvSpPr>
+        <p:spPr>
+          <a:xfrm>
+            <a:off x="6272784" y="5394960"/>
+            <a:ext cx="73152" cy="658368"/>
+          </a:xfrm>
+          <a:prstGeom prst="rect">
+            <a:avLst/>
+          </a:prstGeom>
+          <a:solidFill>
+            <a:srgbClr val="DBEAFE"/>
+          </a:solidFill>
+          <a:ln w="12700">
+            <a:solidFill>
+              <a:srgbClr val="DBEAFE">
+                <a:alpha val="0"/>
+              </a:srgbClr>
+            </a:solidFill>
+            <a:prstDash val="solid"/>
+          </a:ln>
+        </p:spPr>
+      </p:sp>
+      <p:sp>
+        <p:nvSpPr>
+          <p:cNvPr id="18" name="Text 16"/>
           <p:cNvSpPr txBox="1"/>
           <p:nvPr/>
         </p:nvSpPr>
@@ -10397,14 +10806,14 @@
       </p:sp>
       <p:sp>
         <p:nvSpPr>
-          <p:cNvPr id="5" name="Text 3"/>
+          <p:cNvPr id="19" name="Text 17"/>
           <p:cNvSpPr txBox="1"/>
           <p:nvPr/>
         </p:nvSpPr>
         <p:spPr>
           <a:xfrm>
-            <a:off x="987552" y="1572768"/>
-            <a:ext cx="10094976" cy="355092"/>
+            <a:off x="1042416" y="1481328"/>
+            <a:ext cx="4645152" cy="475488"/>
           </a:xfrm>
           <a:prstGeom prst="rect">
             <a:avLst/>
@@ -10416,14 +10825,14 @@
           <a:bodyPr wrap="square" lIns="0" tIns="25400" rIns="25400" bIns="0" rtlCol="0" anchor="ctr"/>
           <a:lstStyle/>
           <a:p>
-            <a:pPr algn="l" indent="0" marL="0">
+            <a:pPr algn="ctr" indent="0" marL="0">
               <a:lnSpc>
                 <a:spcPct val="120000"/>
               </a:lnSpc>
               <a:buNone/>
             </a:pPr>
             <a:r>
-              <a:rPr lang="en-US" sz="2200" dirty="0">
+              <a:rPr lang="en-US" sz="1800" dirty="0">
                 <a:solidFill>
                   <a:srgbClr val="111827"/>
                 </a:solidFill>
@@ -10431,22 +10840,22 @@
                 <a:ea typeface="Pretendard" pitchFamily="34" charset="-122"/>
                 <a:cs typeface="Pretendard" pitchFamily="34" charset="-120"/>
               </a:rPr>
-              <a:t>Preview Purpose</a:t>
+              <a:t>01  Preview Purpose</a:t>
             </a:r>
-            <a:endParaRPr lang="en-US" sz="2200" dirty="0"/>
+            <a:endParaRPr lang="en-US" sz="1800" dirty="0"/>
           </a:p>
         </p:txBody>
       </p:sp>
       <p:sp>
         <p:nvSpPr>
-          <p:cNvPr id="6" name="Text 4"/>
+          <p:cNvPr id="20" name="Text 18"/>
           <p:cNvSpPr txBox="1"/>
           <p:nvPr/>
         </p:nvSpPr>
         <p:spPr>
           <a:xfrm>
-            <a:off x="987552" y="1927860"/>
-            <a:ext cx="10094976" cy="355092"/>
+            <a:off x="1042416" y="2286000"/>
+            <a:ext cx="4645152" cy="475488"/>
           </a:xfrm>
           <a:prstGeom prst="rect">
             <a:avLst/>
@@ -10458,14 +10867,14 @@
           <a:bodyPr wrap="square" lIns="0" tIns="25400" rIns="25400" bIns="0" rtlCol="0" anchor="ctr"/>
           <a:lstStyle/>
           <a:p>
-            <a:pPr algn="l" indent="0" marL="0">
+            <a:pPr algn="ctr" indent="0" marL="0">
               <a:lnSpc>
                 <a:spcPct val="120000"/>
               </a:lnSpc>
               <a:buNone/>
             </a:pPr>
             <a:r>
-              <a:rPr lang="en-US" sz="2200" dirty="0">
+              <a:rPr lang="en-US" sz="1800" dirty="0">
                 <a:solidFill>
                   <a:srgbClr val="111827"/>
                 </a:solidFill>
@@ -10473,22 +10882,22 @@
                 <a:ea typeface="Pretendard" pitchFamily="34" charset="-122"/>
                 <a:cs typeface="Pretendard" pitchFamily="34" charset="-120"/>
               </a:rPr>
-              <a:t>Composition Contract</a:t>
+              <a:t>02  Composition Contract</a:t>
             </a:r>
-            <a:endParaRPr lang="en-US" sz="2200" dirty="0"/>
+            <a:endParaRPr lang="en-US" sz="1800" dirty="0"/>
           </a:p>
         </p:txBody>
       </p:sp>
       <p:sp>
         <p:nvSpPr>
-          <p:cNvPr id="7" name="Text 5"/>
+          <p:cNvPr id="21" name="Text 19"/>
           <p:cNvSpPr txBox="1"/>
           <p:nvPr/>
         </p:nvSpPr>
         <p:spPr>
           <a:xfrm>
-            <a:off x="987552" y="2282952"/>
-            <a:ext cx="10094976" cy="355092"/>
+            <a:off x="1042416" y="3081528"/>
+            <a:ext cx="4645152" cy="475488"/>
           </a:xfrm>
           <a:prstGeom prst="rect">
             <a:avLst/>
@@ -10500,14 +10909,14 @@
           <a:bodyPr wrap="square" lIns="0" tIns="25400" rIns="25400" bIns="0" rtlCol="0" anchor="ctr"/>
           <a:lstStyle/>
           <a:p>
-            <a:pPr algn="l" indent="0" marL="0">
+            <a:pPr algn="ctr" indent="0" marL="0">
               <a:lnSpc>
                 <a:spcPct val="120000"/>
               </a:lnSpc>
               <a:buNone/>
             </a:pPr>
             <a:r>
-              <a:rPr lang="en-US" sz="2200" dirty="0">
+              <a:rPr lang="en-US" sz="1800" dirty="0">
                 <a:solidFill>
                   <a:srgbClr val="111827"/>
                 </a:solidFill>
@@ -10515,22 +10924,22 @@
                 <a:ea typeface="Pretendard" pitchFamily="34" charset="-122"/>
                 <a:cs typeface="Pretendard" pitchFamily="34" charset="-120"/>
               </a:rPr>
-              <a:t>Style Families</a:t>
+              <a:t>03  Style Families</a:t>
             </a:r>
-            <a:endParaRPr lang="en-US" sz="2200" dirty="0"/>
+            <a:endParaRPr lang="en-US" sz="1800" dirty="0"/>
           </a:p>
         </p:txBody>
       </p:sp>
       <p:sp>
         <p:nvSpPr>
-          <p:cNvPr id="8" name="Text 6"/>
+          <p:cNvPr id="22" name="Text 20"/>
           <p:cNvSpPr txBox="1"/>
           <p:nvPr/>
         </p:nvSpPr>
         <p:spPr>
           <a:xfrm>
-            <a:off x="987552" y="2638044"/>
-            <a:ext cx="10094976" cy="355092"/>
+            <a:off x="1042416" y="3886200"/>
+            <a:ext cx="4645152" cy="475488"/>
           </a:xfrm>
           <a:prstGeom prst="rect">
             <a:avLst/>
@@ -10542,14 +10951,14 @@
           <a:bodyPr wrap="square" lIns="0" tIns="25400" rIns="25400" bIns="0" rtlCol="0" anchor="ctr"/>
           <a:lstStyle/>
           <a:p>
-            <a:pPr algn="l" indent="0" marL="0">
+            <a:pPr algn="ctr" indent="0" marL="0">
               <a:lnSpc>
                 <a:spcPct val="120000"/>
               </a:lnSpc>
               <a:buNone/>
             </a:pPr>
             <a:r>
-              <a:rPr lang="en-US" sz="2200" dirty="0">
+              <a:rPr lang="en-US" sz="1800" dirty="0">
                 <a:solidFill>
                   <a:srgbClr val="111827"/>
                 </a:solidFill>
@@ -10557,22 +10966,22 @@
                 <a:ea typeface="Pretendard" pitchFamily="34" charset="-122"/>
                 <a:cs typeface="Pretendard" pitchFamily="34" charset="-120"/>
               </a:rPr>
-              <a:t>Semantic Blocks</a:t>
+              <a:t>04  Semantic Blocks</a:t>
             </a:r>
-            <a:endParaRPr lang="en-US" sz="2200" dirty="0"/>
+            <a:endParaRPr lang="en-US" sz="1800" dirty="0"/>
           </a:p>
         </p:txBody>
       </p:sp>
       <p:sp>
         <p:nvSpPr>
-          <p:cNvPr id="9" name="Text 7"/>
+          <p:cNvPr id="23" name="Text 21"/>
           <p:cNvSpPr txBox="1"/>
           <p:nvPr/>
         </p:nvSpPr>
         <p:spPr>
           <a:xfrm>
-            <a:off x="987552" y="2993136"/>
-            <a:ext cx="10094976" cy="355092"/>
+            <a:off x="1042416" y="4690872"/>
+            <a:ext cx="4645152" cy="475488"/>
           </a:xfrm>
           <a:prstGeom prst="rect">
             <a:avLst/>
@@ -10584,14 +10993,14 @@
           <a:bodyPr wrap="square" lIns="0" tIns="25400" rIns="25400" bIns="0" rtlCol="0" anchor="ctr"/>
           <a:lstStyle/>
           <a:p>
-            <a:pPr algn="l" indent="0" marL="0">
+            <a:pPr algn="ctr" indent="0" marL="0">
               <a:lnSpc>
                 <a:spcPct val="120000"/>
               </a:lnSpc>
               <a:buNone/>
             </a:pPr>
             <a:r>
-              <a:rPr lang="en-US" sz="2200" dirty="0">
+              <a:rPr lang="en-US" sz="1800" dirty="0">
                 <a:solidFill>
                   <a:srgbClr val="111827"/>
                 </a:solidFill>
@@ -10599,22 +11008,22 @@
                 <a:ea typeface="Pretendard" pitchFamily="34" charset="-122"/>
                 <a:cs typeface="Pretendard" pitchFamily="34" charset="-120"/>
               </a:rPr>
-              <a:t>Pipeline Diagram</a:t>
+              <a:t>05  Pipeline Diagram</a:t>
             </a:r>
-            <a:endParaRPr lang="en-US" sz="2200" dirty="0"/>
+            <a:endParaRPr lang="en-US" sz="1800" dirty="0"/>
           </a:p>
         </p:txBody>
       </p:sp>
       <p:sp>
         <p:nvSpPr>
-          <p:cNvPr id="10" name="Text 8"/>
+          <p:cNvPr id="24" name="Text 22"/>
           <p:cNvSpPr txBox="1"/>
           <p:nvPr/>
         </p:nvSpPr>
         <p:spPr>
           <a:xfrm>
-            <a:off x="987552" y="3348228"/>
-            <a:ext cx="10094976" cy="355092"/>
+            <a:off x="1042416" y="5486400"/>
+            <a:ext cx="4645152" cy="475488"/>
           </a:xfrm>
           <a:prstGeom prst="rect">
             <a:avLst/>
@@ -10626,14 +11035,14 @@
           <a:bodyPr wrap="square" lIns="0" tIns="25400" rIns="25400" bIns="0" rtlCol="0" anchor="ctr"/>
           <a:lstStyle/>
           <a:p>
-            <a:pPr algn="l" indent="0" marL="0">
+            <a:pPr algn="ctr" indent="0" marL="0">
               <a:lnSpc>
                 <a:spcPct val="120000"/>
               </a:lnSpc>
               <a:buNone/>
             </a:pPr>
             <a:r>
-              <a:rPr lang="en-US" sz="2200" dirty="0">
+              <a:rPr lang="en-US" sz="1800" dirty="0">
                 <a:solidFill>
                   <a:srgbClr val="111827"/>
                 </a:solidFill>
@@ -10641,22 +11050,22 @@
                 <a:ea typeface="Pretendard" pitchFamily="34" charset="-122"/>
                 <a:cs typeface="Pretendard" pitchFamily="34" charset="-120"/>
               </a:rPr>
-              <a:t>Table Coherence</a:t>
+              <a:t>06  Table Coherence</a:t>
             </a:r>
-            <a:endParaRPr lang="en-US" sz="2200" dirty="0"/>
+            <a:endParaRPr lang="en-US" sz="1800" dirty="0"/>
           </a:p>
         </p:txBody>
       </p:sp>
       <p:sp>
         <p:nvSpPr>
-          <p:cNvPr id="11" name="Text 9"/>
+          <p:cNvPr id="25" name="Text 23"/>
           <p:cNvSpPr txBox="1"/>
           <p:nvPr/>
         </p:nvSpPr>
         <p:spPr>
           <a:xfrm>
-            <a:off x="987552" y="3703320"/>
-            <a:ext cx="10094976" cy="355092"/>
+            <a:off x="6492240" y="1481328"/>
+            <a:ext cx="4645152" cy="475488"/>
           </a:xfrm>
           <a:prstGeom prst="rect">
             <a:avLst/>
@@ -10668,14 +11077,14 @@
           <a:bodyPr wrap="square" lIns="0" tIns="25400" rIns="25400" bIns="0" rtlCol="0" anchor="ctr"/>
           <a:lstStyle/>
           <a:p>
-            <a:pPr algn="l" indent="0" marL="0">
+            <a:pPr algn="ctr" indent="0" marL="0">
               <a:lnSpc>
                 <a:spcPct val="120000"/>
               </a:lnSpc>
               <a:buNone/>
             </a:pPr>
             <a:r>
-              <a:rPr lang="en-US" sz="2200" dirty="0">
+              <a:rPr lang="en-US" sz="1800" dirty="0">
                 <a:solidFill>
                   <a:srgbClr val="111827"/>
                 </a:solidFill>
@@ -10683,22 +11092,22 @@
                 <a:ea typeface="Pretendard" pitchFamily="34" charset="-122"/>
                 <a:cs typeface="Pretendard" pitchFamily="34" charset="-120"/>
               </a:rPr>
-              <a:t>Chart and Table Pair</a:t>
+              <a:t>07  Chart and Table Pair</a:t>
             </a:r>
-            <a:endParaRPr lang="en-US" sz="2200" dirty="0"/>
+            <a:endParaRPr lang="en-US" sz="1800" dirty="0"/>
           </a:p>
         </p:txBody>
       </p:sp>
       <p:sp>
         <p:nvSpPr>
-          <p:cNvPr id="12" name="Text 10"/>
+          <p:cNvPr id="26" name="Text 24"/>
           <p:cNvSpPr txBox="1"/>
           <p:nvPr/>
         </p:nvSpPr>
         <p:spPr>
           <a:xfrm>
-            <a:off x="987552" y="4058412"/>
-            <a:ext cx="10094976" cy="355092"/>
+            <a:off x="6492240" y="2286000"/>
+            <a:ext cx="4645152" cy="475488"/>
           </a:xfrm>
           <a:prstGeom prst="rect">
             <a:avLst/>
@@ -10710,14 +11119,14 @@
           <a:bodyPr wrap="square" lIns="0" tIns="25400" rIns="25400" bIns="0" rtlCol="0" anchor="ctr"/>
           <a:lstStyle/>
           <a:p>
-            <a:pPr algn="l" indent="0" marL="0">
+            <a:pPr algn="ctr" indent="0" marL="0">
               <a:lnSpc>
                 <a:spcPct val="120000"/>
               </a:lnSpc>
               <a:buNone/>
             </a:pPr>
             <a:r>
-              <a:rPr lang="en-US" sz="2200" dirty="0">
+              <a:rPr lang="en-US" sz="1800" dirty="0">
                 <a:solidFill>
                   <a:srgbClr val="111827"/>
                 </a:solidFill>
@@ -10725,22 +11134,22 @@
                 <a:ea typeface="Pretendard" pitchFamily="34" charset="-122"/>
                 <a:cs typeface="Pretendard" pitchFamily="34" charset="-120"/>
               </a:rPr>
-              <a:t>Editable Proof Objects</a:t>
+              <a:t>08  Editable Proof Objects</a:t>
             </a:r>
-            <a:endParaRPr lang="en-US" sz="2200" dirty="0"/>
+            <a:endParaRPr lang="en-US" sz="1800" dirty="0"/>
           </a:p>
         </p:txBody>
       </p:sp>
       <p:sp>
         <p:nvSpPr>
-          <p:cNvPr id="13" name="Text 11"/>
+          <p:cNvPr id="27" name="Text 25"/>
           <p:cNvSpPr txBox="1"/>
           <p:nvPr/>
         </p:nvSpPr>
         <p:spPr>
           <a:xfrm>
-            <a:off x="987552" y="4413504"/>
-            <a:ext cx="10094976" cy="355092"/>
+            <a:off x="6492240" y="3081528"/>
+            <a:ext cx="4645152" cy="475488"/>
           </a:xfrm>
           <a:prstGeom prst="rect">
             <a:avLst/>
@@ -10752,14 +11161,14 @@
           <a:bodyPr wrap="square" lIns="0" tIns="25400" rIns="25400" bIns="0" rtlCol="0" anchor="ctr"/>
           <a:lstStyle/>
           <a:p>
-            <a:pPr algn="l" indent="0" marL="0">
+            <a:pPr algn="ctr" indent="0" marL="0">
               <a:lnSpc>
                 <a:spcPct val="120000"/>
               </a:lnSpc>
               <a:buNone/>
             </a:pPr>
             <a:r>
-              <a:rPr lang="en-US" sz="2200" dirty="0">
+              <a:rPr lang="en-US" sz="1800" dirty="0">
                 <a:solidFill>
                   <a:srgbClr val="111827"/>
                 </a:solidFill>
@@ -10767,22 +11176,22 @@
                 <a:ea typeface="Pretendard" pitchFamily="34" charset="-122"/>
                 <a:cs typeface="Pretendard" pitchFamily="34" charset="-120"/>
               </a:rPr>
-              <a:t>Object Shape Grammar</a:t>
+              <a:t>09  Object Shape Grammar</a:t>
             </a:r>
-            <a:endParaRPr lang="en-US" sz="2200" dirty="0"/>
+            <a:endParaRPr lang="en-US" sz="1800" dirty="0"/>
           </a:p>
         </p:txBody>
       </p:sp>
       <p:sp>
         <p:nvSpPr>
-          <p:cNvPr id="14" name="Text 12"/>
+          <p:cNvPr id="28" name="Text 26"/>
           <p:cNvSpPr txBox="1"/>
           <p:nvPr/>
         </p:nvSpPr>
         <p:spPr>
           <a:xfrm>
-            <a:off x="987552" y="4768596"/>
-            <a:ext cx="10094976" cy="355092"/>
+            <a:off x="6492240" y="3886200"/>
+            <a:ext cx="4645152" cy="475488"/>
           </a:xfrm>
           <a:prstGeom prst="rect">
             <a:avLst/>
@@ -10794,14 +11203,14 @@
           <a:bodyPr wrap="square" lIns="0" tIns="25400" rIns="25400" bIns="0" rtlCol="0" anchor="ctr"/>
           <a:lstStyle/>
           <a:p>
-            <a:pPr algn="l" indent="0" marL="0">
+            <a:pPr algn="ctr" indent="0" marL="0">
               <a:lnSpc>
                 <a:spcPct val="120000"/>
               </a:lnSpc>
               <a:buNone/>
             </a:pPr>
             <a:r>
-              <a:rPr lang="en-US" sz="2200" dirty="0">
+              <a:rPr lang="en-US" sz="1800" dirty="0">
                 <a:solidFill>
                   <a:srgbClr val="111827"/>
                 </a:solidFill>
@@ -10809,22 +11218,22 @@
                 <a:ea typeface="Pretendard" pitchFamily="34" charset="-122"/>
                 <a:cs typeface="Pretendard" pitchFamily="34" charset="-120"/>
               </a:rPr>
-              <a:t>Icon and Text Aside</a:t>
+              <a:t>10  Icon and Text Aside</a:t>
             </a:r>
-            <a:endParaRPr lang="en-US" sz="2200" dirty="0"/>
+            <a:endParaRPr lang="en-US" sz="1800" dirty="0"/>
           </a:p>
         </p:txBody>
       </p:sp>
       <p:sp>
         <p:nvSpPr>
-          <p:cNvPr id="15" name="Text 13"/>
+          <p:cNvPr id="29" name="Text 27"/>
           <p:cNvSpPr txBox="1"/>
           <p:nvPr/>
         </p:nvSpPr>
         <p:spPr>
           <a:xfrm>
-            <a:off x="987552" y="5123688"/>
-            <a:ext cx="10094976" cy="355092"/>
+            <a:off x="6492240" y="4690872"/>
+            <a:ext cx="4645152" cy="475488"/>
           </a:xfrm>
           <a:prstGeom prst="rect">
             <a:avLst/>
@@ -10836,14 +11245,14 @@
           <a:bodyPr wrap="square" lIns="0" tIns="25400" rIns="25400" bIns="0" rtlCol="0" anchor="ctr"/>
           <a:lstStyle/>
           <a:p>
-            <a:pPr algn="l" indent="0" marL="0">
+            <a:pPr algn="ctr" indent="0" marL="0">
               <a:lnSpc>
                 <a:spcPct val="120000"/>
               </a:lnSpc>
               <a:buNone/>
             </a:pPr>
             <a:r>
-              <a:rPr lang="en-US" sz="2200" dirty="0">
+              <a:rPr lang="en-US" sz="1800" dirty="0">
                 <a:solidFill>
                   <a:srgbClr val="111827"/>
                 </a:solidFill>
@@ -10851,22 +11260,22 @@
                 <a:ea typeface="Pretendard" pitchFamily="34" charset="-122"/>
                 <a:cs typeface="Pretendard" pitchFamily="34" charset="-120"/>
               </a:rPr>
-              <a:t>Overflow Guard</a:t>
+              <a:t>11  Overflow Guard</a:t>
             </a:r>
-            <a:endParaRPr lang="en-US" sz="2200" dirty="0"/>
+            <a:endParaRPr lang="en-US" sz="1800" dirty="0"/>
           </a:p>
         </p:txBody>
       </p:sp>
       <p:sp>
         <p:nvSpPr>
-          <p:cNvPr id="16" name="Text 14"/>
+          <p:cNvPr id="30" name="Text 28"/>
           <p:cNvSpPr txBox="1"/>
           <p:nvPr/>
         </p:nvSpPr>
         <p:spPr>
           <a:xfrm>
-            <a:off x="987552" y="5478780"/>
-            <a:ext cx="10094976" cy="355092"/>
+            <a:off x="6492240" y="5486400"/>
+            <a:ext cx="4645152" cy="475488"/>
           </a:xfrm>
           <a:prstGeom prst="rect">
             <a:avLst/>
@@ -10878,14 +11287,14 @@
           <a:bodyPr wrap="square" lIns="0" tIns="25400" rIns="25400" bIns="0" rtlCol="0" anchor="ctr"/>
           <a:lstStyle/>
           <a:p>
-            <a:pPr algn="l" indent="0" marL="0">
+            <a:pPr algn="ctr" indent="0" marL="0">
               <a:lnSpc>
                 <a:spcPct val="120000"/>
               </a:lnSpc>
               <a:buNone/>
             </a:pPr>
             <a:r>
-              <a:rPr lang="en-US" sz="2200" dirty="0">
+              <a:rPr lang="en-US" sz="1800" dirty="0">
                 <a:solidFill>
                   <a:srgbClr val="111827"/>
                 </a:solidFill>
@@ -10893,9 +11302,9 @@
                 <a:ea typeface="Pretendard" pitchFamily="34" charset="-122"/>
                 <a:cs typeface="Pretendard" pitchFamily="34" charset="-120"/>
               </a:rPr>
-              <a:t>Actions Output Review</a:t>
+              <a:t>12  Actions Output Review</a:t>
             </a:r>
-            <a:endParaRPr lang="en-US" sz="2200" dirty="0"/>
+            <a:endParaRPr lang="en-US" sz="1800" dirty="0"/>
           </a:p>
         </p:txBody>
       </p:sp>
@@ -11370,8 +11779,37 @@
         </p:nvSpPr>
         <p:spPr>
           <a:xfrm>
-            <a:off x="914400" y="1417320"/>
-            <a:ext cx="73152" cy="868680"/>
+            <a:off x="786384" y="1956816"/>
+            <a:ext cx="32004" cy="3483864"/>
+          </a:xfrm>
+          <a:prstGeom prst="rect">
+            <a:avLst/>
+          </a:prstGeom>
+          <a:solidFill>
+            <a:srgbClr val="DBEAFE">
+              <a:alpha val="80000"/>
+            </a:srgbClr>
+          </a:solidFill>
+          <a:ln w="12700">
+            <a:solidFill>
+              <a:srgbClr val="DBEAFE">
+                <a:alpha val="0"/>
+              </a:srgbClr>
+            </a:solidFill>
+            <a:prstDash val="solid"/>
+          </a:ln>
+        </p:spPr>
+      </p:sp>
+      <p:sp>
+        <p:nvSpPr>
+          <p:cNvPr id="4" name="Shape 2"/>
+          <p:cNvSpPr/>
+          <p:nvPr/>
+        </p:nvSpPr>
+        <p:spPr>
+          <a:xfrm>
+            <a:off x="914400" y="1865376"/>
+            <a:ext cx="73152" cy="1024128"/>
           </a:xfrm>
           <a:prstGeom prst="rect">
             <a:avLst/>
@@ -11391,14 +11829,14 @@
       </p:sp>
       <p:sp>
         <p:nvSpPr>
-          <p:cNvPr id="4" name="Shape 2"/>
-          <p:cNvSpPr/>
-          <p:nvPr/>
-        </p:nvSpPr>
-        <p:spPr>
-          <a:xfrm>
-            <a:off x="914400" y="2560320"/>
-            <a:ext cx="73152" cy="868680"/>
+          <p:cNvPr id="5" name="Shape 3"/>
+          <p:cNvSpPr/>
+          <p:nvPr/>
+        </p:nvSpPr>
+        <p:spPr>
+          <a:xfrm>
+            <a:off x="914400" y="3191256"/>
+            <a:ext cx="73152" cy="1024128"/>
           </a:xfrm>
           <a:prstGeom prst="rect">
             <a:avLst/>
@@ -11418,14 +11856,14 @@
       </p:sp>
       <p:sp>
         <p:nvSpPr>
-          <p:cNvPr id="5" name="Shape 3"/>
-          <p:cNvSpPr/>
-          <p:nvPr/>
-        </p:nvSpPr>
-        <p:spPr>
-          <a:xfrm>
-            <a:off x="914400" y="3703320"/>
-            <a:ext cx="73152" cy="868680"/>
+          <p:cNvPr id="6" name="Shape 4"/>
+          <p:cNvSpPr/>
+          <p:nvPr/>
+        </p:nvSpPr>
+        <p:spPr>
+          <a:xfrm>
+            <a:off x="914400" y="4507992"/>
+            <a:ext cx="73152" cy="1024128"/>
           </a:xfrm>
           <a:prstGeom prst="rect">
             <a:avLst/>
@@ -11445,7 +11883,7 @@
       </p:sp>
       <p:pic>
         <p:nvPicPr>
-          <p:cNvPr id="6" name="Image 0" descr="preencoded.png">    </p:cNvPr>
+          <p:cNvPr id="7" name="Image 0" descr="preencoded.png">    </p:cNvPr>
           <p:cNvPicPr>
             <a:picLocks noChangeAspect="1"/>
           </p:cNvPicPr>
@@ -11465,8 +11903,8 @@
         </p:blipFill>
         <p:spPr>
           <a:xfrm>
-            <a:off x="914400" y="1417320"/>
-            <a:ext cx="10241280" cy="868680"/>
+            <a:off x="914400" y="1865376"/>
+            <a:ext cx="10241280" cy="1024128"/>
           </a:xfrm>
           <a:prstGeom prst="rect">
             <a:avLst/>
@@ -11475,14 +11913,14 @@
       </p:pic>
       <p:sp>
         <p:nvSpPr>
-          <p:cNvPr id="7" name="Shape 4"/>
-          <p:cNvSpPr/>
-          <p:nvPr/>
-        </p:nvSpPr>
-        <p:spPr>
-          <a:xfrm>
-            <a:off x="914400" y="1417320"/>
-            <a:ext cx="10241280" cy="868680"/>
+          <p:cNvPr id="8" name="Shape 5"/>
+          <p:cNvSpPr/>
+          <p:nvPr/>
+        </p:nvSpPr>
+        <p:spPr>
+          <a:xfrm>
+            <a:off x="914400" y="1865376"/>
+            <a:ext cx="10241280" cy="1024128"/>
           </a:xfrm>
           <a:prstGeom prst="rect">
             <a:avLst/>
@@ -11511,7 +11949,7 @@
       </p:sp>
       <p:pic>
         <p:nvPicPr>
-          <p:cNvPr id="8" name="Image 1" descr="preencoded.png">    </p:cNvPr>
+          <p:cNvPr id="9" name="Image 1" descr="preencoded.png">    </p:cNvPr>
           <p:cNvPicPr>
             <a:picLocks noChangeAspect="1"/>
           </p:cNvPicPr>
@@ -11531,8 +11969,8 @@
         </p:blipFill>
         <p:spPr>
           <a:xfrm>
-            <a:off x="914400" y="2560320"/>
-            <a:ext cx="10241280" cy="868680"/>
+            <a:off x="914400" y="3191256"/>
+            <a:ext cx="10241280" cy="1024128"/>
           </a:xfrm>
           <a:prstGeom prst="rect">
             <a:avLst/>
@@ -11541,14 +11979,14 @@
       </p:pic>
       <p:sp>
         <p:nvSpPr>
-          <p:cNvPr id="9" name="Shape 5"/>
-          <p:cNvSpPr/>
-          <p:nvPr/>
-        </p:nvSpPr>
-        <p:spPr>
-          <a:xfrm>
-            <a:off x="914400" y="2560320"/>
-            <a:ext cx="10241280" cy="868680"/>
+          <p:cNvPr id="10" name="Shape 6"/>
+          <p:cNvSpPr/>
+          <p:nvPr/>
+        </p:nvSpPr>
+        <p:spPr>
+          <a:xfrm>
+            <a:off x="914400" y="3191256"/>
+            <a:ext cx="10241280" cy="1024128"/>
           </a:xfrm>
           <a:prstGeom prst="rect">
             <a:avLst/>
@@ -11577,7 +12015,7 @@
       </p:sp>
       <p:pic>
         <p:nvPicPr>
-          <p:cNvPr id="10" name="Image 2" descr="preencoded.png">    </p:cNvPr>
+          <p:cNvPr id="11" name="Image 2" descr="preencoded.png">    </p:cNvPr>
           <p:cNvPicPr>
             <a:picLocks noChangeAspect="1"/>
           </p:cNvPicPr>
@@ -11597,8 +12035,8 @@
         </p:blipFill>
         <p:spPr>
           <a:xfrm>
-            <a:off x="914400" y="3703320"/>
-            <a:ext cx="10241280" cy="868680"/>
+            <a:off x="914400" y="4507992"/>
+            <a:ext cx="10241280" cy="1024128"/>
           </a:xfrm>
           <a:prstGeom prst="rect">
             <a:avLst/>
@@ -11607,14 +12045,14 @@
       </p:pic>
       <p:sp>
         <p:nvSpPr>
-          <p:cNvPr id="11" name="Shape 6"/>
-          <p:cNvSpPr/>
-          <p:nvPr/>
-        </p:nvSpPr>
-        <p:spPr>
-          <a:xfrm>
-            <a:off x="914400" y="3703320"/>
-            <a:ext cx="10241280" cy="868680"/>
+          <p:cNvPr id="12" name="Shape 7"/>
+          <p:cNvSpPr/>
+          <p:nvPr/>
+        </p:nvSpPr>
+        <p:spPr>
+          <a:xfrm>
+            <a:off x="914400" y="4507992"/>
+            <a:ext cx="10241280" cy="1024128"/>
           </a:xfrm>
           <a:prstGeom prst="rect">
             <a:avLst/>
@@ -11643,7 +12081,7 @@
       </p:sp>
       <p:sp>
         <p:nvSpPr>
-          <p:cNvPr id="12" name="Text 7"/>
+          <p:cNvPr id="13" name="Text 8"/>
           <p:cNvSpPr txBox="1"/>
           <p:nvPr/>
         </p:nvSpPr>
@@ -11685,18 +12123,18 @@
       </p:sp>
       <p:sp>
         <p:nvSpPr>
-          <p:cNvPr id="13" name="Shape 8"/>
-          <p:cNvSpPr/>
-          <p:nvPr/>
-        </p:nvSpPr>
-        <p:spPr>
-          <a:xfrm>
-            <a:off x="1097280" y="1623060"/>
-            <a:ext cx="457200" cy="457200"/>
+          <p:cNvPr id="14" name="Shape 9"/>
+          <p:cNvSpPr/>
+          <p:nvPr/>
+        </p:nvSpPr>
+        <p:spPr>
+          <a:xfrm>
+            <a:off x="1097280" y="2140428"/>
+            <a:ext cx="474025" cy="474025"/>
           </a:xfrm>
           <a:prstGeom prst="roundRect">
             <a:avLst>
-              <a:gd name="adj" fmla="val 8000"/>
+              <a:gd name="adj" fmla="val 7716"/>
             </a:avLst>
           </a:prstGeom>
           <a:solidFill>
@@ -11712,7 +12150,7 @@
       </p:sp>
       <p:pic>
         <p:nvPicPr>
-          <p:cNvPr id="14" name="Image 3" descr="flow icon from tabler-icons (MIT)">    </p:cNvPr>
+          <p:cNvPr id="15" name="Image 3" descr="flow icon from tabler-icons (MIT)">    </p:cNvPr>
           <p:cNvPicPr>
             <a:picLocks noChangeAspect="1"/>
           </p:cNvPicPr>
@@ -11732,8 +12170,8 @@
         </p:blipFill>
         <p:spPr>
           <a:xfrm>
-            <a:off x="1170432" y="1696212"/>
-            <a:ext cx="310896" cy="310896"/>
+            <a:off x="1170432" y="2213580"/>
+            <a:ext cx="327721" cy="327721"/>
           </a:xfrm>
           <a:prstGeom prst="rect">
             <a:avLst/>
@@ -11742,14 +12180,14 @@
       </p:pic>
       <p:sp>
         <p:nvSpPr>
-          <p:cNvPr id="15" name="Text 9"/>
+          <p:cNvPr id="16" name="Text 10"/>
           <p:cNvSpPr txBox="1"/>
           <p:nvPr/>
         </p:nvSpPr>
         <p:spPr>
           <a:xfrm>
-            <a:off x="1682496" y="1508760"/>
-            <a:ext cx="9272016" cy="685800"/>
+            <a:off x="1699321" y="1957548"/>
+            <a:ext cx="9255191" cy="839785"/>
           </a:xfrm>
           <a:prstGeom prst="rect">
             <a:avLst/>
@@ -11801,18 +12239,18 @@
       </p:sp>
       <p:sp>
         <p:nvSpPr>
-          <p:cNvPr id="16" name="Shape 10"/>
-          <p:cNvSpPr/>
-          <p:nvPr/>
-        </p:nvSpPr>
-        <p:spPr>
-          <a:xfrm>
-            <a:off x="1097280" y="2766060"/>
-            <a:ext cx="457200" cy="457200"/>
+          <p:cNvPr id="17" name="Shape 11"/>
+          <p:cNvSpPr/>
+          <p:nvPr/>
+        </p:nvSpPr>
+        <p:spPr>
+          <a:xfrm>
+            <a:off x="1097280" y="3466308"/>
+            <a:ext cx="474025" cy="474025"/>
           </a:xfrm>
           <a:prstGeom prst="roundRect">
             <a:avLst>
-              <a:gd name="adj" fmla="val 8000"/>
+              <a:gd name="adj" fmla="val 7716"/>
             </a:avLst>
           </a:prstGeom>
           <a:solidFill>
@@ -11828,7 +12266,7 @@
       </p:sp>
       <p:pic>
         <p:nvPicPr>
-          <p:cNvPr id="17" name="Image 4" descr="verified icon from tabler-icons (MIT)">    </p:cNvPr>
+          <p:cNvPr id="18" name="Image 4" descr="verified icon from tabler-icons (MIT)">    </p:cNvPr>
           <p:cNvPicPr>
             <a:picLocks noChangeAspect="1"/>
           </p:cNvPicPr>
@@ -11848,8 +12286,8 @@
         </p:blipFill>
         <p:spPr>
           <a:xfrm>
-            <a:off x="1170432" y="2839212"/>
-            <a:ext cx="310896" cy="310896"/>
+            <a:off x="1170432" y="3539460"/>
+            <a:ext cx="327721" cy="327721"/>
           </a:xfrm>
           <a:prstGeom prst="rect">
             <a:avLst/>
@@ -11858,14 +12296,14 @@
       </p:pic>
       <p:sp>
         <p:nvSpPr>
-          <p:cNvPr id="18" name="Text 11"/>
+          <p:cNvPr id="19" name="Text 12"/>
           <p:cNvSpPr txBox="1"/>
           <p:nvPr/>
         </p:nvSpPr>
         <p:spPr>
           <a:xfrm>
-            <a:off x="1682496" y="2651760"/>
-            <a:ext cx="9272016" cy="685800"/>
+            <a:off x="1699321" y="3283428"/>
+            <a:ext cx="9255191" cy="839785"/>
           </a:xfrm>
           <a:prstGeom prst="rect">
             <a:avLst/>
@@ -11917,18 +12355,18 @@
       </p:sp>
       <p:sp>
         <p:nvSpPr>
-          <p:cNvPr id="19" name="Shape 12"/>
-          <p:cNvSpPr/>
-          <p:nvPr/>
-        </p:nvSpPr>
-        <p:spPr>
-          <a:xfrm>
-            <a:off x="1097280" y="3909060"/>
-            <a:ext cx="457200" cy="457200"/>
+          <p:cNvPr id="20" name="Shape 13"/>
+          <p:cNvSpPr/>
+          <p:nvPr/>
+        </p:nvSpPr>
+        <p:spPr>
+          <a:xfrm>
+            <a:off x="1097280" y="4783044"/>
+            <a:ext cx="474025" cy="474025"/>
           </a:xfrm>
           <a:prstGeom prst="roundRect">
             <a:avLst>
-              <a:gd name="adj" fmla="val 8000"/>
+              <a:gd name="adj" fmla="val 7716"/>
             </a:avLst>
           </a:prstGeom>
           <a:solidFill>
@@ -11944,7 +12382,7 @@
       </p:sp>
       <p:pic>
         <p:nvPicPr>
-          <p:cNvPr id="20" name="Image 5" descr="spark icon from tabler-icons (MIT)">    </p:cNvPr>
+          <p:cNvPr id="21" name="Image 5" descr="spark icon from tabler-icons (MIT)">    </p:cNvPr>
           <p:cNvPicPr>
             <a:picLocks noChangeAspect="1"/>
           </p:cNvPicPr>
@@ -11964,8 +12402,8 @@
         </p:blipFill>
         <p:spPr>
           <a:xfrm>
-            <a:off x="1170432" y="3982212"/>
-            <a:ext cx="310896" cy="310896"/>
+            <a:off x="1170432" y="4856196"/>
+            <a:ext cx="327721" cy="327721"/>
           </a:xfrm>
           <a:prstGeom prst="rect">
             <a:avLst/>
@@ -11974,14 +12412,14 @@
       </p:pic>
       <p:sp>
         <p:nvSpPr>
-          <p:cNvPr id="21" name="Text 13"/>
+          <p:cNvPr id="22" name="Text 14"/>
           <p:cNvSpPr txBox="1"/>
           <p:nvPr/>
         </p:nvSpPr>
         <p:spPr>
           <a:xfrm>
-            <a:off x="1682496" y="3794760"/>
-            <a:ext cx="9272016" cy="685800"/>
+            <a:off x="1699321" y="4600164"/>
+            <a:ext cx="9255191" cy="839785"/>
           </a:xfrm>
           <a:prstGeom prst="rect">
             <a:avLst/>
@@ -12371,8 +12809,37 @@
         </p:nvSpPr>
         <p:spPr>
           <a:xfrm>
-            <a:off x="914400" y="1417320"/>
-            <a:ext cx="73152" cy="868680"/>
+            <a:off x="786384" y="1956816"/>
+            <a:ext cx="32004" cy="3483864"/>
+          </a:xfrm>
+          <a:prstGeom prst="rect">
+            <a:avLst/>
+          </a:prstGeom>
+          <a:solidFill>
+            <a:srgbClr val="DBEAFE">
+              <a:alpha val="80000"/>
+            </a:srgbClr>
+          </a:solidFill>
+          <a:ln w="12700">
+            <a:solidFill>
+              <a:srgbClr val="DBEAFE">
+                <a:alpha val="0"/>
+              </a:srgbClr>
+            </a:solidFill>
+            <a:prstDash val="solid"/>
+          </a:ln>
+        </p:spPr>
+      </p:sp>
+      <p:sp>
+        <p:nvSpPr>
+          <p:cNvPr id="4" name="Shape 2"/>
+          <p:cNvSpPr/>
+          <p:nvPr/>
+        </p:nvSpPr>
+        <p:spPr>
+          <a:xfrm>
+            <a:off x="914400" y="1865376"/>
+            <a:ext cx="73152" cy="1024128"/>
           </a:xfrm>
           <a:prstGeom prst="rect">
             <a:avLst/>
@@ -12392,14 +12859,14 @@
       </p:sp>
       <p:sp>
         <p:nvSpPr>
-          <p:cNvPr id="4" name="Shape 2"/>
-          <p:cNvSpPr/>
-          <p:nvPr/>
-        </p:nvSpPr>
-        <p:spPr>
-          <a:xfrm>
-            <a:off x="914400" y="2560320"/>
-            <a:ext cx="73152" cy="868680"/>
+          <p:cNvPr id="5" name="Shape 3"/>
+          <p:cNvSpPr/>
+          <p:nvPr/>
+        </p:nvSpPr>
+        <p:spPr>
+          <a:xfrm>
+            <a:off x="914400" y="3191256"/>
+            <a:ext cx="73152" cy="1024128"/>
           </a:xfrm>
           <a:prstGeom prst="rect">
             <a:avLst/>
@@ -12419,14 +12886,14 @@
       </p:sp>
       <p:sp>
         <p:nvSpPr>
-          <p:cNvPr id="5" name="Shape 3"/>
-          <p:cNvSpPr/>
-          <p:nvPr/>
-        </p:nvSpPr>
-        <p:spPr>
-          <a:xfrm>
-            <a:off x="914400" y="3703320"/>
-            <a:ext cx="73152" cy="868680"/>
+          <p:cNvPr id="6" name="Shape 4"/>
+          <p:cNvSpPr/>
+          <p:nvPr/>
+        </p:nvSpPr>
+        <p:spPr>
+          <a:xfrm>
+            <a:off x="914400" y="4507992"/>
+            <a:ext cx="73152" cy="1024128"/>
           </a:xfrm>
           <a:prstGeom prst="rect">
             <a:avLst/>
@@ -12446,7 +12913,7 @@
       </p:sp>
       <p:pic>
         <p:nvPicPr>
-          <p:cNvPr id="6" name="Image 0" descr="preencoded.png">    </p:cNvPr>
+          <p:cNvPr id="7" name="Image 0" descr="preencoded.png">    </p:cNvPr>
           <p:cNvPicPr>
             <a:picLocks noChangeAspect="1"/>
           </p:cNvPicPr>
@@ -12466,8 +12933,8 @@
         </p:blipFill>
         <p:spPr>
           <a:xfrm>
-            <a:off x="914400" y="1417320"/>
-            <a:ext cx="10241280" cy="868680"/>
+            <a:off x="914400" y="1865376"/>
+            <a:ext cx="10241280" cy="1024128"/>
           </a:xfrm>
           <a:prstGeom prst="rect">
             <a:avLst/>
@@ -12476,14 +12943,14 @@
       </p:pic>
       <p:sp>
         <p:nvSpPr>
-          <p:cNvPr id="7" name="Shape 4"/>
-          <p:cNvSpPr/>
-          <p:nvPr/>
-        </p:nvSpPr>
-        <p:spPr>
-          <a:xfrm>
-            <a:off x="914400" y="1417320"/>
-            <a:ext cx="10241280" cy="868680"/>
+          <p:cNvPr id="8" name="Shape 5"/>
+          <p:cNvSpPr/>
+          <p:nvPr/>
+        </p:nvSpPr>
+        <p:spPr>
+          <a:xfrm>
+            <a:off x="914400" y="1865376"/>
+            <a:ext cx="10241280" cy="1024128"/>
           </a:xfrm>
           <a:prstGeom prst="rect">
             <a:avLst/>
@@ -12512,7 +12979,7 @@
       </p:sp>
       <p:pic>
         <p:nvPicPr>
-          <p:cNvPr id="8" name="Image 1" descr="preencoded.png">    </p:cNvPr>
+          <p:cNvPr id="9" name="Image 1" descr="preencoded.png">    </p:cNvPr>
           <p:cNvPicPr>
             <a:picLocks noChangeAspect="1"/>
           </p:cNvPicPr>
@@ -12532,8 +12999,8 @@
         </p:blipFill>
         <p:spPr>
           <a:xfrm>
-            <a:off x="914400" y="2560320"/>
-            <a:ext cx="10241280" cy="868680"/>
+            <a:off x="914400" y="3191256"/>
+            <a:ext cx="10241280" cy="1024128"/>
           </a:xfrm>
           <a:prstGeom prst="rect">
             <a:avLst/>
@@ -12542,14 +13009,14 @@
       </p:pic>
       <p:sp>
         <p:nvSpPr>
-          <p:cNvPr id="9" name="Shape 5"/>
-          <p:cNvSpPr/>
-          <p:nvPr/>
-        </p:nvSpPr>
-        <p:spPr>
-          <a:xfrm>
-            <a:off x="914400" y="2560320"/>
-            <a:ext cx="10241280" cy="868680"/>
+          <p:cNvPr id="10" name="Shape 6"/>
+          <p:cNvSpPr/>
+          <p:nvPr/>
+        </p:nvSpPr>
+        <p:spPr>
+          <a:xfrm>
+            <a:off x="914400" y="3191256"/>
+            <a:ext cx="10241280" cy="1024128"/>
           </a:xfrm>
           <a:prstGeom prst="rect">
             <a:avLst/>
@@ -12578,7 +13045,7 @@
       </p:sp>
       <p:pic>
         <p:nvPicPr>
-          <p:cNvPr id="10" name="Image 2" descr="preencoded.png">    </p:cNvPr>
+          <p:cNvPr id="11" name="Image 2" descr="preencoded.png">    </p:cNvPr>
           <p:cNvPicPr>
             <a:picLocks noChangeAspect="1"/>
           </p:cNvPicPr>
@@ -12598,8 +13065,8 @@
         </p:blipFill>
         <p:spPr>
           <a:xfrm>
-            <a:off x="914400" y="3703320"/>
-            <a:ext cx="10241280" cy="868680"/>
+            <a:off x="914400" y="4507992"/>
+            <a:ext cx="10241280" cy="1024128"/>
           </a:xfrm>
           <a:prstGeom prst="rect">
             <a:avLst/>
@@ -12608,14 +13075,14 @@
       </p:pic>
       <p:sp>
         <p:nvSpPr>
-          <p:cNvPr id="11" name="Shape 6"/>
-          <p:cNvSpPr/>
-          <p:nvPr/>
-        </p:nvSpPr>
-        <p:spPr>
-          <a:xfrm>
-            <a:off x="914400" y="3703320"/>
-            <a:ext cx="10241280" cy="868680"/>
+          <p:cNvPr id="12" name="Shape 7"/>
+          <p:cNvSpPr/>
+          <p:nvPr/>
+        </p:nvSpPr>
+        <p:spPr>
+          <a:xfrm>
+            <a:off x="914400" y="4507992"/>
+            <a:ext cx="10241280" cy="1024128"/>
           </a:xfrm>
           <a:prstGeom prst="rect">
             <a:avLst/>
@@ -12644,7 +13111,7 @@
       </p:sp>
       <p:sp>
         <p:nvSpPr>
-          <p:cNvPr id="12" name="Text 7"/>
+          <p:cNvPr id="13" name="Text 8"/>
           <p:cNvSpPr txBox="1"/>
           <p:nvPr/>
         </p:nvSpPr>
@@ -12686,18 +13153,18 @@
       </p:sp>
       <p:sp>
         <p:nvSpPr>
-          <p:cNvPr id="13" name="Shape 8"/>
-          <p:cNvSpPr/>
-          <p:nvPr/>
-        </p:nvSpPr>
-        <p:spPr>
-          <a:xfrm>
-            <a:off x="1097280" y="1623060"/>
-            <a:ext cx="457200" cy="457200"/>
+          <p:cNvPr id="14" name="Shape 9"/>
+          <p:cNvSpPr/>
+          <p:nvPr/>
+        </p:nvSpPr>
+        <p:spPr>
+          <a:xfrm>
+            <a:off x="1097280" y="2140428"/>
+            <a:ext cx="474025" cy="474025"/>
           </a:xfrm>
           <a:prstGeom prst="roundRect">
             <a:avLst>
-              <a:gd name="adj" fmla="val 8000"/>
+              <a:gd name="adj" fmla="val 7716"/>
             </a:avLst>
           </a:prstGeom>
           <a:solidFill>
@@ -12713,7 +13180,7 @@
       </p:sp>
       <p:pic>
         <p:nvPicPr>
-          <p:cNvPr id="14" name="Image 3" descr="flow icon from tabler-icons (MIT)">    </p:cNvPr>
+          <p:cNvPr id="15" name="Image 3" descr="flow icon from tabler-icons (MIT)">    </p:cNvPr>
           <p:cNvPicPr>
             <a:picLocks noChangeAspect="1"/>
           </p:cNvPicPr>
@@ -12733,8 +13200,8 @@
         </p:blipFill>
         <p:spPr>
           <a:xfrm>
-            <a:off x="1170432" y="1696212"/>
-            <a:ext cx="310896" cy="310896"/>
+            <a:off x="1170432" y="2213580"/>
+            <a:ext cx="327721" cy="327721"/>
           </a:xfrm>
           <a:prstGeom prst="rect">
             <a:avLst/>
@@ -12743,14 +13210,14 @@
       </p:pic>
       <p:sp>
         <p:nvSpPr>
-          <p:cNvPr id="15" name="Text 9"/>
+          <p:cNvPr id="16" name="Text 10"/>
           <p:cNvSpPr txBox="1"/>
           <p:nvPr/>
         </p:nvSpPr>
         <p:spPr>
           <a:xfrm>
-            <a:off x="1682496" y="1508760"/>
-            <a:ext cx="9272016" cy="685800"/>
+            <a:off x="1699321" y="1957548"/>
+            <a:ext cx="9255191" cy="839785"/>
           </a:xfrm>
           <a:prstGeom prst="rect">
             <a:avLst/>
@@ -12777,7 +13244,7 @@
                 <a:ea typeface="Pretendard" pitchFamily="34" charset="-122"/>
                 <a:cs typeface="Pretendard" pitchFamily="34" charset="-120"/>
               </a:rPr>
-              <a:t>Plain / clean</a:t>
+              <a:t>Clean / minimalism</a:t>
             </a:r>
             <a:pPr algn="l" indent="0" marL="0">
               <a:lnSpc>
@@ -12794,7 +13261,7 @@
                 <a:ea typeface="Pretendard" pitchFamily="34" charset="-122"/>
                 <a:cs typeface="Pretendard" pitchFamily="34" charset="-120"/>
               </a:rPr>
-              <a:t>  low-decoration baselines.</a:t>
+              <a:t>  restrained structural baselines.</a:t>
             </a:r>
             <a:endParaRPr lang="en-US" sz="2200" dirty="0"/>
           </a:p>
@@ -12802,18 +13269,18 @@
       </p:sp>
       <p:sp>
         <p:nvSpPr>
-          <p:cNvPr id="16" name="Shape 10"/>
-          <p:cNvSpPr/>
-          <p:nvPr/>
-        </p:nvSpPr>
-        <p:spPr>
-          <a:xfrm>
-            <a:off x="1097280" y="2766060"/>
-            <a:ext cx="457200" cy="457200"/>
+          <p:cNvPr id="17" name="Shape 11"/>
+          <p:cNvSpPr/>
+          <p:nvPr/>
+        </p:nvSpPr>
+        <p:spPr>
+          <a:xfrm>
+            <a:off x="1097280" y="3466308"/>
+            <a:ext cx="474025" cy="474025"/>
           </a:xfrm>
           <a:prstGeom prst="roundRect">
             <a:avLst>
-              <a:gd name="adj" fmla="val 8000"/>
+              <a:gd name="adj" fmla="val 7716"/>
             </a:avLst>
           </a:prstGeom>
           <a:solidFill>
@@ -12829,7 +13296,7 @@
       </p:sp>
       <p:pic>
         <p:nvPicPr>
-          <p:cNvPr id="17" name="Image 4" descr="verified icon from tabler-icons (MIT)">    </p:cNvPr>
+          <p:cNvPr id="18" name="Image 4" descr="verified icon from tabler-icons (MIT)">    </p:cNvPr>
           <p:cNvPicPr>
             <a:picLocks noChangeAspect="1"/>
           </p:cNvPicPr>
@@ -12849,8 +13316,8 @@
         </p:blipFill>
         <p:spPr>
           <a:xfrm>
-            <a:off x="1170432" y="2839212"/>
-            <a:ext cx="310896" cy="310896"/>
+            <a:off x="1170432" y="3539460"/>
+            <a:ext cx="327721" cy="327721"/>
           </a:xfrm>
           <a:prstGeom prst="rect">
             <a:avLst/>
@@ -12859,14 +13326,14 @@
       </p:pic>
       <p:sp>
         <p:nvSpPr>
-          <p:cNvPr id="18" name="Text 11"/>
+          <p:cNvPr id="19" name="Text 12"/>
           <p:cNvSpPr txBox="1"/>
           <p:nvPr/>
         </p:nvSpPr>
         <p:spPr>
           <a:xfrm>
-            <a:off x="1682496" y="2651760"/>
-            <a:ext cx="9272016" cy="685800"/>
+            <a:off x="1699321" y="3283428"/>
+            <a:ext cx="9255191" cy="839785"/>
           </a:xfrm>
           <a:prstGeom prst="rect">
             <a:avLst/>
@@ -12918,18 +13385,18 @@
       </p:sp>
       <p:sp>
         <p:nvSpPr>
-          <p:cNvPr id="19" name="Shape 12"/>
-          <p:cNvSpPr/>
-          <p:nvPr/>
-        </p:nvSpPr>
-        <p:spPr>
-          <a:xfrm>
-            <a:off x="1097280" y="3909060"/>
-            <a:ext cx="457200" cy="457200"/>
+          <p:cNvPr id="20" name="Shape 13"/>
+          <p:cNvSpPr/>
+          <p:nvPr/>
+        </p:nvSpPr>
+        <p:spPr>
+          <a:xfrm>
+            <a:off x="1097280" y="4783044"/>
+            <a:ext cx="474025" cy="474025"/>
           </a:xfrm>
           <a:prstGeom prst="roundRect">
             <a:avLst>
-              <a:gd name="adj" fmla="val 8000"/>
+              <a:gd name="adj" fmla="val 7716"/>
             </a:avLst>
           </a:prstGeom>
           <a:solidFill>
@@ -12945,7 +13412,7 @@
       </p:sp>
       <p:pic>
         <p:nvPicPr>
-          <p:cNvPr id="20" name="Image 5" descr="spark icon from tabler-icons (MIT)">    </p:cNvPr>
+          <p:cNvPr id="21" name="Image 5" descr="spark icon from tabler-icons (MIT)">    </p:cNvPr>
           <p:cNvPicPr>
             <a:picLocks noChangeAspect="1"/>
           </p:cNvPicPr>
@@ -12965,8 +13432,8 @@
         </p:blipFill>
         <p:spPr>
           <a:xfrm>
-            <a:off x="1170432" y="3982212"/>
-            <a:ext cx="310896" cy="310896"/>
+            <a:off x="1170432" y="4856196"/>
+            <a:ext cx="327721" cy="327721"/>
           </a:xfrm>
           <a:prstGeom prst="rect">
             <a:avLst/>
@@ -12975,14 +13442,14 @@
       </p:pic>
       <p:sp>
         <p:nvSpPr>
-          <p:cNvPr id="21" name="Text 13"/>
+          <p:cNvPr id="22" name="Text 14"/>
           <p:cNvSpPr txBox="1"/>
           <p:nvPr/>
         </p:nvSpPr>
         <p:spPr>
           <a:xfrm>
-            <a:off x="1682496" y="3794760"/>
-            <a:ext cx="9272016" cy="685800"/>
+            <a:off x="1699321" y="4600164"/>
+            <a:ext cx="9255191" cy="839785"/>
           </a:xfrm>
           <a:prstGeom prst="rect">
             <a:avLst/>

</xml_diff>

<commit_message>
Select icons by semantic keyword search
</commit_message>
<xml_diff>
--- a/docs/theme-preview/pptx/clean.pptx
+++ b/docs/theme-preview/pptx/clean.pptx
@@ -8167,7 +8167,7 @@
       </p:sp>
       <p:pic>
         <p:nvPicPr>
-          <p:cNvPr id="17" name="Image 4" descr="flow icon from tabler-icons (MIT)">    </p:cNvPr>
+          <p:cNvPr id="17" name="Image 4" descr="article icon from tabler-icons (MIT)">    </p:cNvPr>
           <p:cNvPicPr>
             <a:picLocks noChangeAspect="1"/>
           </p:cNvPicPr>
@@ -8283,7 +8283,7 @@
       </p:sp>
       <p:pic>
         <p:nvPicPr>
-          <p:cNvPr id="20" name="Image 5" descr="verified icon from tabler-icons (MIT)">    </p:cNvPr>
+          <p:cNvPr id="20" name="Image 5" descr="article icon from tabler-icons (MIT)">    </p:cNvPr>
           <p:cNvPicPr>
             <a:picLocks noChangeAspect="1"/>
           </p:cNvPicPr>
@@ -8399,7 +8399,7 @@
       </p:sp>
       <p:pic>
         <p:nvPicPr>
-          <p:cNvPr id="23" name="Image 6" descr="spark icon from tabler-icons (MIT)">    </p:cNvPr>
+          <p:cNvPr id="23" name="Image 6" descr="article icon from tabler-icons (MIT)">    </p:cNvPr>
           <p:cNvPicPr>
             <a:picLocks noChangeAspect="1"/>
           </p:cNvPicPr>
@@ -8515,7 +8515,7 @@
       </p:sp>
       <p:pic>
         <p:nvPicPr>
-          <p:cNvPr id="26" name="Image 7" descr="chart icon from tabler-icons (MIT)">    </p:cNvPr>
+          <p:cNvPr id="26" name="Image 7" descr="table icon from tabler-icons (MIT)">    </p:cNvPr>
           <p:cNvPicPr>
             <a:picLocks noChangeAspect="1"/>
           </p:cNvPicPr>
@@ -9104,7 +9104,7 @@
       </p:sp>
       <p:pic>
         <p:nvPicPr>
-          <p:cNvPr id="17" name="Image 4" descr="flow icon from tabler-icons (MIT)">    </p:cNvPr>
+          <p:cNvPr id="17" name="Image 4" descr="verified icon from tabler-icons (MIT)">    </p:cNvPr>
           <p:cNvPicPr>
             <a:picLocks noChangeAspect="1"/>
           </p:cNvPicPr>
@@ -9220,7 +9220,7 @@
       </p:sp>
       <p:pic>
         <p:nvPicPr>
-          <p:cNvPr id="20" name="Image 5" descr="verified icon from tabler-icons (MIT)">    </p:cNvPr>
+          <p:cNvPr id="20" name="Image 5" descr="table icon from tabler-icons (MIT)">    </p:cNvPr>
           <p:cNvPicPr>
             <a:picLocks noChangeAspect="1"/>
           </p:cNvPicPr>
@@ -9336,7 +9336,7 @@
       </p:sp>
       <p:pic>
         <p:nvPicPr>
-          <p:cNvPr id="23" name="Image 6" descr="spark icon from tabler-icons (MIT)">    </p:cNvPr>
+          <p:cNvPr id="23" name="Image 6" descr="article icon from tabler-icons (MIT)">    </p:cNvPr>
           <p:cNvPicPr>
             <a:picLocks noChangeAspect="1"/>
           </p:cNvPicPr>
@@ -9452,7 +9452,7 @@
       </p:sp>
       <p:pic>
         <p:nvPicPr>
-          <p:cNvPr id="26" name="Image 7" descr="chart icon from tabler-icons (MIT)">    </p:cNvPr>
+          <p:cNvPr id="26" name="Image 7" descr="article icon from tabler-icons (MIT)">    </p:cNvPr>
           <p:cNvPicPr>
             <a:picLocks noChangeAspect="1"/>
           </p:cNvPicPr>
@@ -12150,7 +12150,7 @@
       </p:sp>
       <p:pic>
         <p:nvPicPr>
-          <p:cNvPr id="15" name="Image 3" descr="flow icon from tabler-icons (MIT)">    </p:cNvPr>
+          <p:cNvPr id="15" name="Image 3" descr="article icon from tabler-icons (MIT)">    </p:cNvPr>
           <p:cNvPicPr>
             <a:picLocks noChangeAspect="1"/>
           </p:cNvPicPr>
@@ -12266,7 +12266,7 @@
       </p:sp>
       <p:pic>
         <p:nvPicPr>
-          <p:cNvPr id="18" name="Image 4" descr="verified icon from tabler-icons (MIT)">    </p:cNvPr>
+          <p:cNvPr id="18" name="Image 4" descr="chart icon from tabler-icons (MIT)">    </p:cNvPr>
           <p:cNvPicPr>
             <a:picLocks noChangeAspect="1"/>
           </p:cNvPicPr>
@@ -12382,7 +12382,7 @@
       </p:sp>
       <p:pic>
         <p:nvPicPr>
-          <p:cNvPr id="21" name="Image 5" descr="spark icon from tabler-icons (MIT)">    </p:cNvPr>
+          <p:cNvPr id="21" name="Image 5" descr="article icon from tabler-icons (MIT)">    </p:cNvPr>
           <p:cNvPicPr>
             <a:picLocks noChangeAspect="1"/>
           </p:cNvPicPr>
@@ -13180,7 +13180,7 @@
       </p:sp>
       <p:pic>
         <p:nvPicPr>
-          <p:cNvPr id="15" name="Image 3" descr="flow icon from tabler-icons (MIT)">    </p:cNvPr>
+          <p:cNvPr id="15" name="Image 3" descr="article icon from tabler-icons (MIT)">    </p:cNvPr>
           <p:cNvPicPr>
             <a:picLocks noChangeAspect="1"/>
           </p:cNvPicPr>
@@ -13296,7 +13296,7 @@
       </p:sp>
       <p:pic>
         <p:nvPicPr>
-          <p:cNvPr id="18" name="Image 4" descr="verified icon from tabler-icons (MIT)">    </p:cNvPr>
+          <p:cNvPr id="18" name="Image 4" descr="article icon from tabler-icons (MIT)">    </p:cNvPr>
           <p:cNvPicPr>
             <a:picLocks noChangeAspect="1"/>
           </p:cNvPicPr>
@@ -13412,7 +13412,7 @@
       </p:sp>
       <p:pic>
         <p:nvPicPr>
-          <p:cNvPr id="21" name="Image 5" descr="spark icon from tabler-icons (MIT)">    </p:cNvPr>
+          <p:cNvPr id="21" name="Image 5" descr="article icon from tabler-icons (MIT)">    </p:cNvPr>
           <p:cNvPicPr>
             <a:picLocks noChangeAspect="1"/>
           </p:cNvPicPr>
@@ -14274,7 +14274,7 @@
       </p:sp>
       <p:pic>
         <p:nvPicPr>
-          <p:cNvPr id="17" name="Image 4" descr="flow icon from tabler-icons (MIT)">    </p:cNvPr>
+          <p:cNvPr id="17" name="Image 4" descr="table icon from tabler-icons (MIT)">    </p:cNvPr>
           <p:cNvPicPr>
             <a:picLocks noChangeAspect="1"/>
           </p:cNvPicPr>
@@ -14390,7 +14390,7 @@
       </p:sp>
       <p:pic>
         <p:nvPicPr>
-          <p:cNvPr id="20" name="Image 5" descr="verified icon from tabler-icons (MIT)">    </p:cNvPr>
+          <p:cNvPr id="20" name="Image 5" descr="article icon from tabler-icons (MIT)">    </p:cNvPr>
           <p:cNvPicPr>
             <a:picLocks noChangeAspect="1"/>
           </p:cNvPicPr>
@@ -14506,7 +14506,7 @@
       </p:sp>
       <p:pic>
         <p:nvPicPr>
-          <p:cNvPr id="23" name="Image 6" descr="spark icon from tabler-icons (MIT)">    </p:cNvPr>
+          <p:cNvPr id="23" name="Image 6" descr="article icon from tabler-icons (MIT)">    </p:cNvPr>
           <p:cNvPicPr>
             <a:picLocks noChangeAspect="1"/>
           </p:cNvPicPr>
@@ -14622,7 +14622,7 @@
       </p:sp>
       <p:pic>
         <p:nvPicPr>
-          <p:cNvPr id="26" name="Image 7" descr="chart icon from tabler-icons (MIT)">    </p:cNvPr>
+          <p:cNvPr id="26" name="Image 7" descr="table icon from tabler-icons (MIT)">    </p:cNvPr>
           <p:cNvPicPr>
             <a:picLocks noChangeAspect="1"/>
           </p:cNvPicPr>

</xml_diff>

<commit_message>
Harden theme preview QA checks
</commit_message>
<xml_diff>
--- a/docs/theme-preview/pptx/clean.pptx
+++ b/docs/theme-preview/pptx/clean.pptx
@@ -3004,36 +3004,75 @@
           </a:ln>
         </p:spPr>
       </p:sp>
-      <p:sp>
-        <p:nvSpPr>
-          <p:cNvPr id="3" name="Shape 1"/>
-          <p:cNvSpPr/>
-          <p:nvPr/>
-        </p:nvSpPr>
-        <p:spPr>
-          <a:xfrm>
-            <a:off x="914400" y="1463040"/>
-            <a:ext cx="10241280" cy="73152"/>
-          </a:xfrm>
-          <a:prstGeom prst="rect">
-            <a:avLst/>
-          </a:prstGeom>
-          <a:solidFill>
-            <a:srgbClr val="2563EB"/>
-          </a:solidFill>
-          <a:ln w="12700">
-            <a:solidFill>
-              <a:srgbClr val="2563EB">
+      <p:pic>
+        <p:nvPicPr>
+          <p:cNvPr id="3" name="Image 0" descr="preencoded.png">    </p:cNvPr>
+          <p:cNvPicPr>
+            <a:picLocks noChangeAspect="1"/>
+          </p:cNvPicPr>
+          <p:nvPr/>
+        </p:nvPicPr>
+        <p:blipFill>
+          <a:blip r:embed="rId1">
+            <a:extLst>
+              <a:ext uri="{96DAC541-7B7A-43D3-8B79-37D633B846F1}">
+                <asvg:svgBlip xmlns:asvg="http://schemas.microsoft.com/office/drawing/2016/SVG/main" r:embed="rId2"/>
+              </a:ext>
+            </a:extLst>
+          </a:blip>
+          <a:stretch>
+            <a:fillRect/>
+          </a:stretch>
+        </p:blipFill>
+        <p:spPr>
+          <a:xfrm>
+            <a:off x="914400" y="1417320"/>
+            <a:ext cx="10241280" cy="4526280"/>
+          </a:xfrm>
+          <a:prstGeom prst="rect">
+            <a:avLst/>
+          </a:prstGeom>
+        </p:spPr>
+      </p:pic>
+      <p:sp>
+        <p:nvSpPr>
+          <p:cNvPr id="4" name="Shape 1"/>
+          <p:cNvSpPr/>
+          <p:nvPr/>
+        </p:nvSpPr>
+        <p:spPr>
+          <a:xfrm>
+            <a:off x="914400" y="1417320"/>
+            <a:ext cx="10241280" cy="4526280"/>
+          </a:xfrm>
+          <a:prstGeom prst="rect">
+            <a:avLst/>
+          </a:prstGeom>
+          <a:solidFill>
+            <a:srgbClr val="FFFFFF">
+              <a:alpha val="0"/>
+            </a:srgbClr>
+          </a:solidFill>
+          <a:ln w="12700">
+            <a:solidFill>
+              <a:srgbClr val="E2E8F0">
                 <a:alpha val="0"/>
               </a:srgbClr>
             </a:solidFill>
             <a:prstDash val="solid"/>
           </a:ln>
-        </p:spPr>
-      </p:sp>
-      <p:sp>
-        <p:nvSpPr>
-          <p:cNvPr id="4" name="Text 2"/>
+          <a:effectLst>
+            <a:outerShdw sx="100000" sy="100000" kx="0" ky="0" algn="bl" rotWithShape="0" blurRad="12700" dist="50800" dir="2700000">
+              <a:srgbClr val="000000">
+                <a:alpha val="8000"/>
+              </a:srgbClr>
+            </a:outerShdw>
+          </a:effectLst>
+        </p:spPr>
+      </p:sp>
+      <p:sp>
+        <p:nvSpPr>
+          <p:cNvPr id="5" name="Text 2"/>
           <p:cNvSpPr txBox="1"/>
           <p:nvPr/>
         </p:nvSpPr>
@@ -3088,8 +3127,8 @@
           </p:nvPr>
         </p:nvGraphicFramePr>
         <p:xfrm>
-          <a:off x="914400" y="1463040"/>
-          <a:ext cx="10241280" cy="4480560"/>
+          <a:off x="914400" y="1417320"/>
+          <a:ext cx="10241280" cy="4526280"/>
         </p:xfrm>
         <a:graphic>
           <a:graphicData uri="http://schemas.openxmlformats.org/drawingml/2006/table">
@@ -3100,7 +3139,7 @@
                 <a:gridCol w="3413760"/>
                 <a:gridCol w="3413760"/>
               </a:tblGrid>
-              <a:tr h="896112">
+              <a:tr h="905256">
                 <a:tc>
                   <a:txBody>
                     <a:bodyPr/>
@@ -3110,7 +3149,7 @@
                         <a:buNone/>
                       </a:pPr>
                       <a:r>
-                        <a:rPr lang="en-US" sz="2200" b="1" dirty="0">
+                        <a:rPr lang="en-US" sz="1800" b="1" dirty="0">
                           <a:solidFill>
                             <a:srgbClr val="FFFFFF"/>
                           </a:solidFill>
@@ -3120,7 +3159,7 @@
                         </a:rPr>
                         <a:t>Object</a:t>
                       </a:r>
-                      <a:endParaRPr lang="en-US" sz="2200" dirty="0">
+                      <a:endParaRPr lang="en-US" sz="1800" dirty="0">
                         <a:latin typeface="Pretendard" charset="0"/>
                         <a:ea typeface="Pretendard" charset="0"/>
                         <a:cs typeface="Pretendard" charset="0"/>
@@ -3178,7 +3217,7 @@
                         <a:buNone/>
                       </a:pPr>
                       <a:r>
-                        <a:rPr lang="en-US" sz="2200" b="1" dirty="0">
+                        <a:rPr lang="en-US" sz="1800" b="1" dirty="0">
                           <a:solidFill>
                             <a:srgbClr val="FFFFFF"/>
                           </a:solidFill>
@@ -3188,7 +3227,7 @@
                         </a:rPr>
                         <a:t>Renderer expectation</a:t>
                       </a:r>
-                      <a:endParaRPr lang="en-US" sz="2200" dirty="0">
+                      <a:endParaRPr lang="en-US" sz="1800" dirty="0">
                         <a:latin typeface="Pretendard" charset="0"/>
                         <a:ea typeface="Pretendard" charset="0"/>
                         <a:cs typeface="Pretendard" charset="0"/>
@@ -3246,7 +3285,7 @@
                         <a:buNone/>
                       </a:pPr>
                       <a:r>
-                        <a:rPr lang="en-US" sz="2200" b="1" dirty="0">
+                        <a:rPr lang="en-US" sz="1800" b="1" dirty="0">
                           <a:solidFill>
                             <a:srgbClr val="FFFFFF"/>
                           </a:solidFill>
@@ -3256,7 +3295,7 @@
                         </a:rPr>
                         <a:t>QA signal</a:t>
                       </a:r>
-                      <a:endParaRPr lang="en-US" sz="2200" dirty="0">
+                      <a:endParaRPr lang="en-US" sz="1800" dirty="0">
                         <a:latin typeface="Pretendard" charset="0"/>
                         <a:ea typeface="Pretendard" charset="0"/>
                         <a:cs typeface="Pretendard" charset="0"/>
@@ -3306,7 +3345,7 @@
                   </a:tcPr>
                 </a:tc>
               </a:tr>
-              <a:tr h="896112">
+              <a:tr h="905256">
                 <a:tc>
                   <a:txBody>
                     <a:bodyPr/>
@@ -3316,7 +3355,7 @@
                         <a:buNone/>
                       </a:pPr>
                       <a:r>
-                        <a:rPr lang="en-US" sz="2200" b="1" dirty="0">
+                        <a:rPr lang="en-US" sz="1800" b="1" dirty="0">
                           <a:solidFill>
                             <a:srgbClr val="111827"/>
                           </a:solidFill>
@@ -3326,7 +3365,7 @@
                         </a:rPr>
                         <a:t>Text box</a:t>
                       </a:r>
-                      <a:endParaRPr lang="en-US" sz="2200" dirty="0">
+                      <a:endParaRPr lang="en-US" sz="1800" dirty="0">
                         <a:latin typeface="Pretendard" charset="0"/>
                         <a:ea typeface="Pretendard" charset="0"/>
                         <a:cs typeface="Pretendard" charset="0"/>
@@ -3381,7 +3420,7 @@
                         <a:buNone/>
                       </a:pPr>
                       <a:r>
-                        <a:rPr lang="en-US" sz="2200" dirty="0">
+                        <a:rPr lang="en-US" sz="1800" dirty="0">
                           <a:solidFill>
                             <a:srgbClr val="111827"/>
                           </a:solidFill>
@@ -3391,7 +3430,7 @@
                         </a:rPr>
                         <a:t>editable, middle aligned</a:t>
                       </a:r>
-                      <a:endParaRPr lang="en-US" sz="2200" dirty="0">
+                      <a:endParaRPr lang="en-US" sz="1800" dirty="0">
                         <a:latin typeface="Pretendard" charset="0"/>
                         <a:ea typeface="Pretendard" charset="0"/>
                         <a:cs typeface="Pretendard" charset="0"/>
@@ -3446,7 +3485,7 @@
                         <a:buNone/>
                       </a:pPr>
                       <a:r>
-                        <a:rPr lang="en-US" sz="2200" dirty="0">
+                        <a:rPr lang="en-US" sz="1800" dirty="0">
                           <a:solidFill>
                             <a:srgbClr val="111827"/>
                           </a:solidFill>
@@ -3456,7 +3495,7 @@
                         </a:rPr>
                         <a:t>readable minimum size</a:t>
                       </a:r>
-                      <a:endParaRPr lang="en-US" sz="2200" dirty="0">
+                      <a:endParaRPr lang="en-US" sz="1800" dirty="0">
                         <a:latin typeface="Pretendard" charset="0"/>
                         <a:ea typeface="Pretendard" charset="0"/>
                         <a:cs typeface="Pretendard" charset="0"/>
@@ -3503,7 +3542,7 @@
                   </a:tcPr>
                 </a:tc>
               </a:tr>
-              <a:tr h="896112">
+              <a:tr h="905256">
                 <a:tc>
                   <a:txBody>
                     <a:bodyPr/>
@@ -3513,7 +3552,7 @@
                         <a:buNone/>
                       </a:pPr>
                       <a:r>
-                        <a:rPr lang="en-US" sz="2200" b="1" dirty="0">
+                        <a:rPr lang="en-US" sz="1800" b="1" dirty="0">
                           <a:solidFill>
                             <a:srgbClr val="111827"/>
                           </a:solidFill>
@@ -3523,7 +3562,7 @@
                         </a:rPr>
                         <a:t>Table</a:t>
                       </a:r>
-                      <a:endParaRPr lang="en-US" sz="2200" dirty="0">
+                      <a:endParaRPr lang="en-US" sz="1800" dirty="0">
                         <a:latin typeface="Pretendard" charset="0"/>
                         <a:ea typeface="Pretendard" charset="0"/>
                         <a:cs typeface="Pretendard" charset="0"/>
@@ -3583,7 +3622,7 @@
                         <a:buNone/>
                       </a:pPr>
                       <a:r>
-                        <a:rPr lang="en-US" sz="2200" dirty="0">
+                        <a:rPr lang="en-US" sz="1800" dirty="0">
                           <a:solidFill>
                             <a:srgbClr val="111827"/>
                           </a:solidFill>
@@ -3593,7 +3632,7 @@
                         </a:rPr>
                         <a:t>native table object</a:t>
                       </a:r>
-                      <a:endParaRPr lang="en-US" sz="2200" dirty="0">
+                      <a:endParaRPr lang="en-US" sz="1800" dirty="0">
                         <a:latin typeface="Pretendard" charset="0"/>
                         <a:ea typeface="Pretendard" charset="0"/>
                         <a:cs typeface="Pretendard" charset="0"/>
@@ -3653,7 +3692,7 @@
                         <a:buNone/>
                       </a:pPr>
                       <a:r>
-                        <a:rPr lang="en-US" sz="2200" dirty="0">
+                        <a:rPr lang="en-US" sz="1800" dirty="0">
                           <a:solidFill>
                             <a:srgbClr val="111827"/>
                           </a:solidFill>
@@ -3663,7 +3702,7 @@
                         </a:rPr>
                         <a:t>header fill and cell padding</a:t>
                       </a:r>
-                      <a:endParaRPr lang="en-US" sz="2200" dirty="0">
+                      <a:endParaRPr lang="en-US" sz="1800" dirty="0">
                         <a:latin typeface="Pretendard" charset="0"/>
                         <a:ea typeface="Pretendard" charset="0"/>
                         <a:cs typeface="Pretendard" charset="0"/>
@@ -3715,7 +3754,7 @@
                   </a:tcPr>
                 </a:tc>
               </a:tr>
-              <a:tr h="896112">
+              <a:tr h="905256">
                 <a:tc>
                   <a:txBody>
                     <a:bodyPr/>
@@ -3725,7 +3764,7 @@
                         <a:buNone/>
                       </a:pPr>
                       <a:r>
-                        <a:rPr lang="en-US" sz="2200" b="1" dirty="0">
+                        <a:rPr lang="en-US" sz="1800" b="1" dirty="0">
                           <a:solidFill>
                             <a:srgbClr val="111827"/>
                           </a:solidFill>
@@ -3735,7 +3774,7 @@
                         </a:rPr>
                         <a:t>Diagram</a:t>
                       </a:r>
-                      <a:endParaRPr lang="en-US" sz="2200" dirty="0">
+                      <a:endParaRPr lang="en-US" sz="1800" dirty="0">
                         <a:latin typeface="Pretendard" charset="0"/>
                         <a:ea typeface="Pretendard" charset="0"/>
                         <a:cs typeface="Pretendard" charset="0"/>
@@ -3790,7 +3829,7 @@
                         <a:buNone/>
                       </a:pPr>
                       <a:r>
-                        <a:rPr lang="en-US" sz="2200" dirty="0">
+                        <a:rPr lang="en-US" sz="1800" dirty="0">
                           <a:solidFill>
                             <a:srgbClr val="111827"/>
                           </a:solidFill>
@@ -3800,7 +3839,7 @@
                         </a:rPr>
                         <a:t>nodes and connectors</a:t>
                       </a:r>
-                      <a:endParaRPr lang="en-US" sz="2200" dirty="0">
+                      <a:endParaRPr lang="en-US" sz="1800" dirty="0">
                         <a:latin typeface="Pretendard" charset="0"/>
                         <a:ea typeface="Pretendard" charset="0"/>
                         <a:cs typeface="Pretendard" charset="0"/>
@@ -3855,7 +3894,7 @@
                         <a:buNone/>
                       </a:pPr>
                       <a:r>
-                        <a:rPr lang="en-US" sz="2200" dirty="0">
+                        <a:rPr lang="en-US" sz="1800" dirty="0">
                           <a:solidFill>
                             <a:srgbClr val="111827"/>
                           </a:solidFill>
@@ -3865,7 +3904,7 @@
                         </a:rPr>
                         <a:t>no clipped labels</a:t>
                       </a:r>
-                      <a:endParaRPr lang="en-US" sz="2200" dirty="0">
+                      <a:endParaRPr lang="en-US" sz="1800" dirty="0">
                         <a:latin typeface="Pretendard" charset="0"/>
                         <a:ea typeface="Pretendard" charset="0"/>
                         <a:cs typeface="Pretendard" charset="0"/>
@@ -3912,7 +3951,7 @@
                   </a:tcPr>
                 </a:tc>
               </a:tr>
-              <a:tr h="896112">
+              <a:tr h="905256">
                 <a:tc>
                   <a:txBody>
                     <a:bodyPr/>
@@ -3922,7 +3961,7 @@
                         <a:buNone/>
                       </a:pPr>
                       <a:r>
-                        <a:rPr lang="en-US" sz="2200" b="1" dirty="0">
+                        <a:rPr lang="en-US" sz="1800" b="1" dirty="0">
                           <a:solidFill>
                             <a:srgbClr val="111827"/>
                           </a:solidFill>
@@ -3932,7 +3971,7 @@
                         </a:rPr>
                         <a:t>Chart</a:t>
                       </a:r>
-                      <a:endParaRPr lang="en-US" sz="2200" dirty="0">
+                      <a:endParaRPr lang="en-US" sz="1800" dirty="0">
                         <a:latin typeface="Pretendard" charset="0"/>
                         <a:ea typeface="Pretendard" charset="0"/>
                         <a:cs typeface="Pretendard" charset="0"/>
@@ -3992,7 +4031,7 @@
                         <a:buNone/>
                       </a:pPr>
                       <a:r>
-                        <a:rPr lang="en-US" sz="2200" dirty="0">
+                        <a:rPr lang="en-US" sz="1800" dirty="0">
                           <a:solidFill>
                             <a:srgbClr val="111827"/>
                           </a:solidFill>
@@ -4002,7 +4041,7 @@
                         </a:rPr>
                         <a:t>theme-colored data object</a:t>
                       </a:r>
-                      <a:endParaRPr lang="en-US" sz="2200" dirty="0">
+                      <a:endParaRPr lang="en-US" sz="1800" dirty="0">
                         <a:latin typeface="Pretendard" charset="0"/>
                         <a:ea typeface="Pretendard" charset="0"/>
                         <a:cs typeface="Pretendard" charset="0"/>
@@ -4062,7 +4101,7 @@
                         <a:buNone/>
                       </a:pPr>
                       <a:r>
-                        <a:rPr lang="en-US" sz="2200" dirty="0">
+                        <a:rPr lang="en-US" sz="1800" dirty="0">
                           <a:solidFill>
                             <a:srgbClr val="111827"/>
                           </a:solidFill>
@@ -4072,7 +4111,7 @@
                         </a:rPr>
                         <a:t>contrast and value clarity</a:t>
                       </a:r>
-                      <a:endParaRPr lang="en-US" sz="2200" dirty="0">
+                      <a:endParaRPr lang="en-US" sz="1800" dirty="0">
                         <a:latin typeface="Pretendard" charset="0"/>
                         <a:ea typeface="Pretendard" charset="0"/>
                         <a:cs typeface="Pretendard" charset="0"/>
@@ -4536,36 +4575,75 @@
           </a:ln>
         </p:spPr>
       </p:sp>
-      <p:sp>
-        <p:nvSpPr>
-          <p:cNvPr id="3" name="Shape 1"/>
-          <p:cNvSpPr/>
-          <p:nvPr/>
-        </p:nvSpPr>
-        <p:spPr>
-          <a:xfrm>
-            <a:off x="914400" y="1463040"/>
-            <a:ext cx="10241280" cy="73152"/>
-          </a:xfrm>
-          <a:prstGeom prst="rect">
-            <a:avLst/>
-          </a:prstGeom>
-          <a:solidFill>
-            <a:srgbClr val="2563EB"/>
-          </a:solidFill>
-          <a:ln w="12700">
-            <a:solidFill>
-              <a:srgbClr val="2563EB">
+      <p:pic>
+        <p:nvPicPr>
+          <p:cNvPr id="3" name="Image 0" descr="preencoded.png">    </p:cNvPr>
+          <p:cNvPicPr>
+            <a:picLocks noChangeAspect="1"/>
+          </p:cNvPicPr>
+          <p:nvPr/>
+        </p:nvPicPr>
+        <p:blipFill>
+          <a:blip r:embed="rId1">
+            <a:extLst>
+              <a:ext uri="{96DAC541-7B7A-43D3-8B79-37D633B846F1}">
+                <asvg:svgBlip xmlns:asvg="http://schemas.microsoft.com/office/drawing/2016/SVG/main" r:embed="rId2"/>
+              </a:ext>
+            </a:extLst>
+          </a:blip>
+          <a:stretch>
+            <a:fillRect/>
+          </a:stretch>
+        </p:blipFill>
+        <p:spPr>
+          <a:xfrm>
+            <a:off x="914400" y="1417320"/>
+            <a:ext cx="10241280" cy="4526280"/>
+          </a:xfrm>
+          <a:prstGeom prst="rect">
+            <a:avLst/>
+          </a:prstGeom>
+        </p:spPr>
+      </p:pic>
+      <p:sp>
+        <p:nvSpPr>
+          <p:cNvPr id="4" name="Shape 1"/>
+          <p:cNvSpPr/>
+          <p:nvPr/>
+        </p:nvSpPr>
+        <p:spPr>
+          <a:xfrm>
+            <a:off x="914400" y="1417320"/>
+            <a:ext cx="10241280" cy="4526280"/>
+          </a:xfrm>
+          <a:prstGeom prst="rect">
+            <a:avLst/>
+          </a:prstGeom>
+          <a:solidFill>
+            <a:srgbClr val="FFFFFF">
+              <a:alpha val="0"/>
+            </a:srgbClr>
+          </a:solidFill>
+          <a:ln w="12700">
+            <a:solidFill>
+              <a:srgbClr val="E2E8F0">
                 <a:alpha val="0"/>
               </a:srgbClr>
             </a:solidFill>
             <a:prstDash val="solid"/>
           </a:ln>
-        </p:spPr>
-      </p:sp>
-      <p:sp>
-        <p:nvSpPr>
-          <p:cNvPr id="4" name="Text 2"/>
+          <a:effectLst>
+            <a:outerShdw sx="100000" sy="100000" kx="0" ky="0" algn="bl" rotWithShape="0" blurRad="12700" dist="50800" dir="2700000">
+              <a:srgbClr val="000000">
+                <a:alpha val="8000"/>
+              </a:srgbClr>
+            </a:outerShdw>
+          </a:effectLst>
+        </p:spPr>
+      </p:sp>
+      <p:sp>
+        <p:nvSpPr>
+          <p:cNvPr id="5" name="Text 2"/>
           <p:cNvSpPr txBox="1"/>
           <p:nvPr/>
         </p:nvSpPr>
@@ -4620,8 +4698,8 @@
           </p:nvPr>
         </p:nvGraphicFramePr>
         <p:xfrm>
-          <a:off x="914400" y="1463040"/>
-          <a:ext cx="10241280" cy="4480560"/>
+          <a:off x="914400" y="1417320"/>
+          <a:ext cx="10241280" cy="4526280"/>
         </p:xfrm>
         <a:graphic>
           <a:graphicData uri="http://schemas.openxmlformats.org/drawingml/2006/table">
@@ -4632,7 +4710,7 @@
                 <a:gridCol w="3413760"/>
                 <a:gridCol w="3413760"/>
               </a:tblGrid>
-              <a:tr h="1120140">
+              <a:tr h="1131570">
                 <a:tc>
                   <a:txBody>
                     <a:bodyPr/>
@@ -4642,7 +4720,7 @@
                         <a:buNone/>
                       </a:pPr>
                       <a:r>
-                        <a:rPr lang="en-US" sz="2200" b="1" dirty="0">
+                        <a:rPr lang="en-US" sz="1800" b="1" dirty="0">
                           <a:solidFill>
                             <a:srgbClr val="FFFFFF"/>
                           </a:solidFill>
@@ -4652,7 +4730,7 @@
                         </a:rPr>
                         <a:t>Stage</a:t>
                       </a:r>
-                      <a:endParaRPr lang="en-US" sz="2200" dirty="0">
+                      <a:endParaRPr lang="en-US" sz="1800" dirty="0">
                         <a:latin typeface="Pretendard" charset="0"/>
                         <a:ea typeface="Pretendard" charset="0"/>
                         <a:cs typeface="Pretendard" charset="0"/>
@@ -4710,7 +4788,7 @@
                         <a:buNone/>
                       </a:pPr>
                       <a:r>
-                        <a:rPr lang="en-US" sz="2200" b="1" dirty="0">
+                        <a:rPr lang="en-US" sz="1800" b="1" dirty="0">
                           <a:solidFill>
                             <a:srgbClr val="FFFFFF"/>
                           </a:solidFill>
@@ -4720,7 +4798,7 @@
                         </a:rPr>
                         <a:t>Coverage</a:t>
                       </a:r>
-                      <a:endParaRPr lang="en-US" sz="2200" dirty="0">
+                      <a:endParaRPr lang="en-US" sz="1800" dirty="0">
                         <a:latin typeface="Pretendard" charset="0"/>
                         <a:ea typeface="Pretendard" charset="0"/>
                         <a:cs typeface="Pretendard" charset="0"/>
@@ -4778,7 +4856,7 @@
                         <a:buNone/>
                       </a:pPr>
                       <a:r>
-                        <a:rPr lang="en-US" sz="2200" b="1" dirty="0">
+                        <a:rPr lang="en-US" sz="1800" b="1" dirty="0">
                           <a:solidFill>
                             <a:srgbClr val="FFFFFF"/>
                           </a:solidFill>
@@ -4788,7 +4866,7 @@
                         </a:rPr>
                         <a:t>Defects</a:t>
                       </a:r>
-                      <a:endParaRPr lang="en-US" sz="2200" dirty="0">
+                      <a:endParaRPr lang="en-US" sz="1800" dirty="0">
                         <a:latin typeface="Pretendard" charset="0"/>
                         <a:ea typeface="Pretendard" charset="0"/>
                         <a:cs typeface="Pretendard" charset="0"/>
@@ -4838,7 +4916,7 @@
                   </a:tcPr>
                 </a:tc>
               </a:tr>
-              <a:tr h="1120140">
+              <a:tr h="1131570">
                 <a:tc>
                   <a:txBody>
                     <a:bodyPr/>
@@ -4848,7 +4926,7 @@
                         <a:buNone/>
                       </a:pPr>
                       <a:r>
-                        <a:rPr lang="en-US" sz="2200" b="1" dirty="0">
+                        <a:rPr lang="en-US" sz="1800" b="1" dirty="0">
                           <a:solidFill>
                             <a:srgbClr val="111827"/>
                           </a:solidFill>
@@ -4858,7 +4936,7 @@
                         </a:rPr>
                         <a:t>Parser</a:t>
                       </a:r>
-                      <a:endParaRPr lang="en-US" sz="2200" dirty="0">
+                      <a:endParaRPr lang="en-US" sz="1800" dirty="0">
                         <a:latin typeface="Pretendard" charset="0"/>
                         <a:ea typeface="Pretendard" charset="0"/>
                         <a:cs typeface="Pretendard" charset="0"/>
@@ -4913,7 +4991,7 @@
                         <a:buNone/>
                       </a:pPr>
                       <a:r>
-                        <a:rPr lang="en-US" sz="2200" dirty="0">
+                        <a:rPr lang="en-US" sz="1800" dirty="0">
                           <a:solidFill>
                             <a:srgbClr val="111827"/>
                           </a:solidFill>
@@ -4923,7 +5001,7 @@
                         </a:rPr>
                         <a:t>92</a:t>
                       </a:r>
-                      <a:endParaRPr lang="en-US" sz="2200" dirty="0">
+                      <a:endParaRPr lang="en-US" sz="1800" dirty="0">
                         <a:latin typeface="Pretendard" charset="0"/>
                         <a:ea typeface="Pretendard" charset="0"/>
                         <a:cs typeface="Pretendard" charset="0"/>
@@ -4978,7 +5056,7 @@
                         <a:buNone/>
                       </a:pPr>
                       <a:r>
-                        <a:rPr lang="en-US" sz="2200" dirty="0">
+                        <a:rPr lang="en-US" sz="1800" dirty="0">
                           <a:solidFill>
                             <a:srgbClr val="111827"/>
                           </a:solidFill>
@@ -4988,7 +5066,7 @@
                         </a:rPr>
                         <a:t>3</a:t>
                       </a:r>
-                      <a:endParaRPr lang="en-US" sz="2200" dirty="0">
+                      <a:endParaRPr lang="en-US" sz="1800" dirty="0">
                         <a:latin typeface="Pretendard" charset="0"/>
                         <a:ea typeface="Pretendard" charset="0"/>
                         <a:cs typeface="Pretendard" charset="0"/>
@@ -5035,7 +5113,7 @@
                   </a:tcPr>
                 </a:tc>
               </a:tr>
-              <a:tr h="1120140">
+              <a:tr h="1131570">
                 <a:tc>
                   <a:txBody>
                     <a:bodyPr/>
@@ -5045,7 +5123,7 @@
                         <a:buNone/>
                       </a:pPr>
                       <a:r>
-                        <a:rPr lang="en-US" sz="2200" b="1" dirty="0">
+                        <a:rPr lang="en-US" sz="1800" b="1" dirty="0">
                           <a:solidFill>
                             <a:srgbClr val="111827"/>
                           </a:solidFill>
@@ -5055,7 +5133,7 @@
                         </a:rPr>
                         <a:t>Layout</a:t>
                       </a:r>
-                      <a:endParaRPr lang="en-US" sz="2200" dirty="0">
+                      <a:endParaRPr lang="en-US" sz="1800" dirty="0">
                         <a:latin typeface="Pretendard" charset="0"/>
                         <a:ea typeface="Pretendard" charset="0"/>
                         <a:cs typeface="Pretendard" charset="0"/>
@@ -5115,7 +5193,7 @@
                         <a:buNone/>
                       </a:pPr>
                       <a:r>
-                        <a:rPr lang="en-US" sz="2200" dirty="0">
+                        <a:rPr lang="en-US" sz="1800" dirty="0">
                           <a:solidFill>
                             <a:srgbClr val="111827"/>
                           </a:solidFill>
@@ -5125,7 +5203,7 @@
                         </a:rPr>
                         <a:t>88</a:t>
                       </a:r>
-                      <a:endParaRPr lang="en-US" sz="2200" dirty="0">
+                      <a:endParaRPr lang="en-US" sz="1800" dirty="0">
                         <a:latin typeface="Pretendard" charset="0"/>
                         <a:ea typeface="Pretendard" charset="0"/>
                         <a:cs typeface="Pretendard" charset="0"/>
@@ -5185,7 +5263,7 @@
                         <a:buNone/>
                       </a:pPr>
                       <a:r>
-                        <a:rPr lang="en-US" sz="2200" dirty="0">
+                        <a:rPr lang="en-US" sz="1800" dirty="0">
                           <a:solidFill>
                             <a:srgbClr val="111827"/>
                           </a:solidFill>
@@ -5195,7 +5273,7 @@
                         </a:rPr>
                         <a:t>5</a:t>
                       </a:r>
-                      <a:endParaRPr lang="en-US" sz="2200" dirty="0">
+                      <a:endParaRPr lang="en-US" sz="1800" dirty="0">
                         <a:latin typeface="Pretendard" charset="0"/>
                         <a:ea typeface="Pretendard" charset="0"/>
                         <a:cs typeface="Pretendard" charset="0"/>
@@ -5247,7 +5325,7 @@
                   </a:tcPr>
                 </a:tc>
               </a:tr>
-              <a:tr h="1120140">
+              <a:tr h="1131570">
                 <a:tc>
                   <a:txBody>
                     <a:bodyPr/>
@@ -5257,7 +5335,7 @@
                         <a:buNone/>
                       </a:pPr>
                       <a:r>
-                        <a:rPr lang="en-US" sz="2200" b="1" dirty="0">
+                        <a:rPr lang="en-US" sz="1800" b="1" dirty="0">
                           <a:solidFill>
                             <a:srgbClr val="111827"/>
                           </a:solidFill>
@@ -5267,7 +5345,7 @@
                         </a:rPr>
                         <a:t>PPTX</a:t>
                       </a:r>
-                      <a:endParaRPr lang="en-US" sz="2200" dirty="0">
+                      <a:endParaRPr lang="en-US" sz="1800" dirty="0">
                         <a:latin typeface="Pretendard" charset="0"/>
                         <a:ea typeface="Pretendard" charset="0"/>
                         <a:cs typeface="Pretendard" charset="0"/>
@@ -5322,7 +5400,7 @@
                         <a:buNone/>
                       </a:pPr>
                       <a:r>
-                        <a:rPr lang="en-US" sz="2200" dirty="0">
+                        <a:rPr lang="en-US" sz="1800" dirty="0">
                           <a:solidFill>
                             <a:srgbClr val="111827"/>
                           </a:solidFill>
@@ -5332,7 +5410,7 @@
                         </a:rPr>
                         <a:t>95</a:t>
                       </a:r>
-                      <a:endParaRPr lang="en-US" sz="2200" dirty="0">
+                      <a:endParaRPr lang="en-US" sz="1800" dirty="0">
                         <a:latin typeface="Pretendard" charset="0"/>
                         <a:ea typeface="Pretendard" charset="0"/>
                         <a:cs typeface="Pretendard" charset="0"/>
@@ -5387,7 +5465,7 @@
                         <a:buNone/>
                       </a:pPr>
                       <a:r>
-                        <a:rPr lang="en-US" sz="2200" dirty="0">
+                        <a:rPr lang="en-US" sz="1800" dirty="0">
                           <a:solidFill>
                             <a:srgbClr val="111827"/>
                           </a:solidFill>
@@ -5397,7 +5475,7 @@
                         </a:rPr>
                         <a:t>2</a:t>
                       </a:r>
-                      <a:endParaRPr lang="en-US" sz="2200" dirty="0">
+                      <a:endParaRPr lang="en-US" sz="1800" dirty="0">
                         <a:latin typeface="Pretendard" charset="0"/>
                         <a:ea typeface="Pretendard" charset="0"/>
                         <a:cs typeface="Pretendard" charset="0"/>

</xml_diff>